<commit_message>
docs: update README and CLAUDE.md for DeepSeek architecture
</commit_message>
<xml_diff>
--- a/demo/demo1.pptx
+++ b/demo/demo1.pptx
@@ -32,9 +32,6 @@
     <p:sldId id="280" r:id="rId31"/>
     <p:sldId id="281" r:id="rId32"/>
     <p:sldId id="282" r:id="rId33"/>
-    <p:sldId id="283" r:id="rId34"/>
-    <p:sldId id="284" r:id="rId35"/>
-    <p:sldId id="285" r:id="rId36"/>
   </p:sldIdLst>
   <p:sldSz cx="12191695" cy="6858000" type="screen4x3"/>
   <p:notesSz cx="6858000" cy="9144000"/>
@@ -3148,7 +3145,7 @@
               </a:defRPr>
             </a:pPr>
             <a:r>
-              <a:t>2027 Fall 英国商业分析硕士选校与申请规划</a:t>
+              <a:t>2027秋 英国商业分析硕士：选校与申请规划</a:t>
             </a:r>
           </a:p>
         </p:txBody>
@@ -3184,7 +3181,7 @@
               </a:defRPr>
             </a:pPr>
             <a:r>
-              <a:t>为计划申请英国BA硕士的中国学生打造的战略指南</a:t>
+              <a:t>帝国理工 × UCL × 华威 × 爱丁堡｜从认知到行动的完整作战图</a:t>
             </a:r>
           </a:p>
         </p:txBody>
@@ -3238,7 +3235,7 @@
               </a:defRPr>
             </a:pPr>
             <a:r>
-              <a:t>Imperial：课程特色与Capstone</a:t>
+              <a:t>Warwick：MSc Business Analytics &amp; AI 项目概览</a:t>
             </a:r>
           </a:p>
         </p:txBody>
@@ -3277,71 +3274,71 @@
               </a:defRPr>
             </a:pPr>
             <a:r>
-              <a:t>机器学习与数据 analytics：从监督学习到无监督学习的商业应用</a:t>
-            </a:r>
-          </a:p>
-          <a:p>
-            <a:pPr>
-              <a:spcAft>
-                <a:spcPts val="1200"/>
-              </a:spcAft>
-              <a:defRPr sz="1800">
-                <a:solidFill>
-                  <a:srgbClr val="333333"/>
-                </a:solidFill>
-                <a:latin typeface="Microsoft YaHei"/>
-              </a:defRPr>
-            </a:pPr>
-            <a:r>
-              <a:t>预测分析与数据可视化：掌握时间序列、预测模型与交互式仪表盘</a:t>
-            </a:r>
-          </a:p>
-          <a:p>
-            <a:pPr>
-              <a:spcAft>
-                <a:spcPts val="1200"/>
-              </a:spcAft>
-              <a:defRPr sz="1800">
-                <a:solidFill>
-                  <a:srgbClr val="333333"/>
-                </a:solidFill>
-                <a:latin typeface="Microsoft YaHei"/>
-              </a:defRPr>
-            </a:pPr>
-            <a:r>
-              <a:t>网络分析（Network Analytics）：理解社交网络与供应链中的关系数据</a:t>
-            </a:r>
-          </a:p>
-          <a:p>
-            <a:pPr>
-              <a:spcAft>
-                <a:spcPts val="1200"/>
-              </a:spcAft>
-              <a:defRPr sz="1800">
-                <a:solidFill>
-                  <a:srgbClr val="333333"/>
-                </a:solidFill>
-                <a:latin typeface="Microsoft YaHei"/>
-              </a:defRPr>
-            </a:pPr>
-            <a:r>
-              <a:t>Capstone Project：与企业合作解决真实商业问题，产出可直接写入简历的成果</a:t>
-            </a:r>
-          </a:p>
-          <a:p>
-            <a:pPr>
-              <a:spcAft>
-                <a:spcPts val="1200"/>
-              </a:spcAft>
-              <a:defRPr sz="1800">
-                <a:solidFill>
-                  <a:srgbClr val="333333"/>
-                </a:solidFill>
-                <a:latin typeface="Microsoft YaHei"/>
-              </a:defRPr>
-            </a:pPr>
-            <a:r>
-              <a:t>选修方向：可延伸至金融、医疗、咨询等垂直领域的数据应用</a:t>
+              <a:t>项目：MSc Business Analytics &amp; AI（2026入学起由原MSc Business Analytics升级更名）｜华威商学院WBS</a:t>
+            </a:r>
+          </a:p>
+          <a:p>
+            <a:pPr>
+              <a:spcAft>
+                <a:spcPts val="1200"/>
+              </a:spcAft>
+              <a:defRPr sz="1800">
+                <a:solidFill>
+                  <a:srgbClr val="333333"/>
+                </a:solidFill>
+                <a:latin typeface="Microsoft YaHei"/>
+              </a:defRPr>
+            </a:pPr>
+            <a:r>
+              <a:t>时长：1年全日制；地点：华威校区（Coventry，距伦敦约1.5小时火车）</a:t>
+            </a:r>
+          </a:p>
+          <a:p>
+            <a:pPr>
+              <a:spcAft>
+                <a:spcPts val="1200"/>
+              </a:spcAft>
+              <a:defRPr sz="1800">
+                <a:solidFill>
+                  <a:srgbClr val="333333"/>
+                </a:solidFill>
+                <a:latin typeface="Microsoft YaHei"/>
+              </a:defRPr>
+            </a:pPr>
+            <a:r>
+              <a:t>学费：2026年国际生£38,150（官网已公布）；2027年未公布；申请费£75</a:t>
+            </a:r>
+          </a:p>
+          <a:p>
+            <a:pPr>
+              <a:spcAft>
+                <a:spcPts val="1200"/>
+              </a:spcAft>
+              <a:defRPr sz="1800">
+                <a:solidFill>
+                  <a:srgbClr val="333333"/>
+                </a:solidFill>
+                <a:latin typeface="Microsoft YaHei"/>
+              </a:defRPr>
+            </a:pPr>
+            <a:r>
+              <a:t>课程：描述性/预测性/规范性分析全覆盖；Tableau可视化、机器学习、统计、优化；可选考ACAP认证（INFORMS/The OR Society）</a:t>
+            </a:r>
+          </a:p>
+          <a:p>
+            <a:pPr>
+              <a:spcAft>
+                <a:spcPts val="1200"/>
+              </a:spcAft>
+              <a:defRPr sz="1800">
+                <a:solidFill>
+                  <a:srgbClr val="333333"/>
+                </a:solidFill>
+                <a:latin typeface="Microsoft YaHei"/>
+              </a:defRPr>
+            </a:pPr>
+            <a:r>
+              <a:t>四大专业方向：预测与规范性分析、人工智能、管理分析（供应链/金融）、营销分析与技术</a:t>
             </a:r>
           </a:p>
         </p:txBody>
@@ -3395,7 +3392,7 @@
               </a:defRPr>
             </a:pPr>
             <a:r>
-              <a:t>Imperial：申请门槛与费用详情</a:t>
+              <a:t>Warwick：申请要求与资源</a:t>
             </a:r>
           </a:p>
         </p:txBody>
@@ -3434,71 +3431,71 @@
               </a:defRPr>
             </a:pPr>
             <a:r>
-              <a:t>学术要求：英制First或Upper Second Class Honours（2:1）学位，且须为定量学科背景</a:t>
-            </a:r>
-          </a:p>
-          <a:p>
-            <a:pPr>
-              <a:spcAft>
-                <a:spcPts val="1200"/>
-              </a:spcAft>
-              <a:defRPr sz="1800">
-                <a:solidFill>
-                  <a:srgbClr val="333333"/>
-                </a:solidFill>
-                <a:latin typeface="Microsoft YaHei"/>
-              </a:defRPr>
-            </a:pPr>
-            <a:r>
-              <a:t>GMAT/GRE：非强制但强烈建议提交；建议GMAT不低于600或GRE Quantitative不低于159</a:t>
-            </a:r>
-          </a:p>
-          <a:p>
-            <a:pPr>
-              <a:spcAft>
-                <a:spcPts val="1200"/>
-              </a:spcAft>
-              <a:defRPr sz="1800">
-                <a:solidFill>
-                  <a:srgbClr val="333333"/>
-                </a:solidFill>
-                <a:latin typeface="Microsoft YaHei"/>
-              </a:defRPr>
-            </a:pPr>
-            <a:r>
-              <a:t>语言要求：需提供合格雅思/托福成绩；具体豁免政策请参考官网</a:t>
-            </a:r>
-          </a:p>
-          <a:p>
-            <a:pPr>
-              <a:spcAft>
-                <a:spcPts val="1200"/>
-              </a:spcAft>
-              <a:defRPr sz="1800">
-                <a:solidFill>
-                  <a:srgbClr val="333333"/>
-                </a:solidFill>
-                <a:latin typeface="Microsoft YaHei"/>
-              </a:defRPr>
-            </a:pPr>
-            <a:r>
-              <a:t>2025/2026学费：£47,000/年；延长实习路径可能产生额外费用</a:t>
-            </a:r>
-          </a:p>
-          <a:p>
-            <a:pPr>
-              <a:spcAft>
-                <a:spcPts val="1200"/>
-              </a:spcAft>
-              <a:defRPr sz="1800">
-                <a:solidFill>
-                  <a:srgbClr val="333333"/>
-                </a:solidFill>
-                <a:latin typeface="Microsoft YaHei"/>
-              </a:defRPr>
-            </a:pPr>
-            <a:r>
-              <a:t>2027学费状态：Not yet published，预计2025年底至2026年公布</a:t>
+              <a:t>学历：2:1以上，接受广泛专业（经济、商科、工程、心理、地理、社会学、政治），须证明强数理/IT/统计能力</a:t>
+            </a:r>
+          </a:p>
+          <a:p>
+            <a:pPr>
+              <a:spcAft>
+                <a:spcPts val="1200"/>
+              </a:spcAft>
+              <a:defRPr sz="1800">
+                <a:solidFill>
+                  <a:srgbClr val="333333"/>
+                </a:solidFill>
+                <a:latin typeface="Microsoft YaHei"/>
+              </a:defRPr>
+            </a:pPr>
+            <a:r>
+              <a:t>语言：Band B——雅思7.0，其中两单项6.0/6.5、其余7.0及以上</a:t>
+            </a:r>
+          </a:p>
+          <a:p>
+            <a:pPr>
+              <a:spcAft>
+                <a:spcPts val="1200"/>
+              </a:spcAft>
+              <a:defRPr sz="1800">
+                <a:solidFill>
+                  <a:srgbClr val="333333"/>
+                </a:solidFill>
+                <a:latin typeface="Microsoft YaHei"/>
+              </a:defRPr>
+            </a:pPr>
+            <a:r>
+              <a:t>GMAT/GRE：官方不要求；量化背景偏弱者可主动提供以加分</a:t>
+            </a:r>
+          </a:p>
+          <a:p>
+            <a:pPr>
+              <a:spcAft>
+                <a:spcPts val="1200"/>
+              </a:spcAft>
+              <a:defRPr sz="1800">
+                <a:solidFill>
+                  <a:srgbClr val="333333"/>
+                </a:solidFill>
+                <a:latin typeface="Microsoft YaHei"/>
+              </a:defRPr>
+            </a:pPr>
+            <a:r>
+              <a:t>流程：申请费£75；录取后4周内缴£2,500押金；滚动审理、先到先得（2026入学统一截止8月2日）</a:t>
+            </a:r>
+          </a:p>
+          <a:p>
+            <a:pPr>
+              <a:spcAft>
+                <a:spcPts val="1200"/>
+              </a:spcAft>
+              <a:defRPr sz="1800">
+                <a:solidFill>
+                  <a:srgbClr val="333333"/>
+                </a:solidFill>
+                <a:latin typeface="Microsoft YaHei"/>
+              </a:defRPr>
+            </a:pPr>
+            <a:r>
+              <a:t>资源：WBS CareersPlus专属职业团队；奖学金池£150万+（学费减免10%-50%）；往届雇主含Accenture、EY、KPMG</a:t>
             </a:r>
           </a:p>
         </p:txBody>
@@ -3552,7 +3549,7 @@
               </a:defRPr>
             </a:pPr>
             <a:r>
-              <a:t>Imperial：差异化优势与申请策略</a:t>
+              <a:t>Edinburgh：MSc Business Analytics 项目概览</a:t>
             </a:r>
           </a:p>
         </p:txBody>
@@ -3591,71 +3588,71 @@
               </a:defRPr>
             </a:pPr>
             <a:r>
-              <a:t>品牌与排名：帝国理工在全球STEM与商科领域享有极高声誉</a:t>
-            </a:r>
-          </a:p>
-          <a:p>
-            <a:pPr>
-              <a:spcAft>
-                <a:spcPts val="1200"/>
-              </a:spcAft>
-              <a:defRPr sz="1800">
-                <a:solidFill>
-                  <a:srgbClr val="333333"/>
-                </a:solidFill>
-                <a:latin typeface="Microsoft YaHei"/>
-              </a:defRPr>
-            </a:pPr>
-            <a:r>
-              <a:t>地理位置：位于伦敦南肯辛顿，紧邻金融城与科技公司聚集区</a:t>
-            </a:r>
-          </a:p>
-          <a:p>
-            <a:pPr>
-              <a:spcAft>
-                <a:spcPts val="1200"/>
-              </a:spcAft>
-              <a:defRPr sz="1800">
-                <a:solidFill>
-                  <a:srgbClr val="333333"/>
-                </a:solidFill>
-                <a:latin typeface="Microsoft YaHei"/>
-              </a:defRPr>
-            </a:pPr>
-            <a:r>
-              <a:t>就业服务：强校友网络与职业中心支持，定期举办行业招聘活动</a:t>
-            </a:r>
-          </a:p>
-          <a:p>
-            <a:pPr>
-              <a:spcAft>
-                <a:spcPts val="1200"/>
-              </a:spcAft>
-              <a:defRPr sz="1800">
-                <a:solidFill>
-                  <a:srgbClr val="333333"/>
-                </a:solidFill>
-                <a:latin typeface="Microsoft YaHei"/>
-              </a:defRPr>
-            </a:pPr>
-            <a:r>
-              <a:t>2027申请策略：建议赶前两轮提交，以避开后期名额紧缩与签证时间压力</a:t>
-            </a:r>
-          </a:p>
-          <a:p>
-            <a:pPr>
-              <a:spcAft>
-                <a:spcPts val="1200"/>
-              </a:spcAft>
-              <a:defRPr sz="1800">
-                <a:solidFill>
-                  <a:srgbClr val="333333"/>
-                </a:solidFill>
-                <a:latin typeface="Microsoft YaHei"/>
-              </a:defRPr>
-            </a:pPr>
-            <a:r>
-              <a:t>风险提示：班级规模有限（约96人），竞争极为激烈，需突出量化背景与职业目标的匹配度</a:t>
+              <a:t>项目：MSc Business Analytics｜爱丁堡大学商学院（University of Edinburgh Business School）</a:t>
+            </a:r>
+          </a:p>
+          <a:p>
+            <a:pPr>
+              <a:spcAft>
+                <a:spcPts val="1200"/>
+              </a:spcAft>
+              <a:defRPr sz="1800">
+                <a:solidFill>
+                  <a:srgbClr val="333333"/>
+                </a:solidFill>
+                <a:latin typeface="Microsoft YaHei"/>
+              </a:defRPr>
+            </a:pPr>
+            <a:r>
+              <a:t>时长：1年全日制；地点：苏格兰首府爱丁堡</a:t>
+            </a:r>
+          </a:p>
+          <a:p>
+            <a:pPr>
+              <a:spcAft>
+                <a:spcPts val="1200"/>
+              </a:spcAft>
+              <a:defRPr sz="1800">
+                <a:solidFill>
+                  <a:srgbClr val="333333"/>
+                </a:solidFill>
+                <a:latin typeface="Microsoft YaHei"/>
+              </a:defRPr>
+            </a:pPr>
+            <a:r>
+              <a:t>学费：2026年入学国际生£34,800（官方已公布）；2027年未公布</a:t>
+            </a:r>
+          </a:p>
+          <a:p>
+            <a:pPr>
+              <a:spcAft>
+                <a:spcPts val="1200"/>
+              </a:spcAft>
+              <a:defRPr sz="1800">
+                <a:solidFill>
+                  <a:srgbClr val="333333"/>
+                </a:solidFill>
+                <a:latin typeface="Microsoft YaHei"/>
+              </a:defRPr>
+            </a:pPr>
+            <a:r>
+              <a:t>课程特色：运筹学、统计学、数据分析与机器学习的融合，强调『数据+技术+商业领导力』</a:t>
+            </a:r>
+          </a:p>
+          <a:p>
+            <a:pPr>
+              <a:spcAft>
+                <a:spcPts val="1200"/>
+              </a:spcAft>
+              <a:defRPr sz="1800">
+                <a:solidFill>
+                  <a:srgbClr val="333333"/>
+                </a:solidFill>
+                <a:latin typeface="Microsoft YaHei"/>
+              </a:defRPr>
+            </a:pPr>
+            <a:r>
+              <a:t>排名：QS 2026商业分析硕士全球第26；QS 2026欧洲大学排名第6</a:t>
             </a:r>
           </a:p>
         </p:txBody>
@@ -3709,7 +3706,7 @@
               </a:defRPr>
             </a:pPr>
             <a:r>
-              <a:t>UCL：项目概览</a:t>
+              <a:t>Edinburgh：申请要求与录取机制</a:t>
             </a:r>
           </a:p>
         </p:txBody>
@@ -3748,71 +3745,71 @@
               </a:defRPr>
             </a:pPr>
             <a:r>
-              <a:t>项目名称：MSc Business Analytics，UCL School of Management</a:t>
-            </a:r>
-          </a:p>
-          <a:p>
-            <a:pPr>
-              <a:spcAft>
-                <a:spcPts val="1200"/>
-              </a:spcAft>
-              <a:defRPr sz="1800">
-                <a:solidFill>
-                  <a:srgbClr val="333333"/>
-                </a:solidFill>
-                <a:latin typeface="Microsoft YaHei"/>
-              </a:defRPr>
-            </a:pPr>
-            <a:r>
-              <a:t>学制与地点：全日制一年，伦敦金丝雀码头校区（Canary Wharf）</a:t>
-            </a:r>
-          </a:p>
-          <a:p>
-            <a:pPr>
-              <a:spcAft>
-                <a:spcPts val="1200"/>
-              </a:spcAft>
-              <a:defRPr sz="1800">
-                <a:solidFill>
-                  <a:srgbClr val="333333"/>
-                </a:solidFill>
-                <a:latin typeface="Microsoft YaHei"/>
-              </a:defRPr>
-            </a:pPr>
-            <a:r>
-              <a:t>课程定位：STEM导向，融合数据分析、机器学习与商业战略</a:t>
-            </a:r>
-          </a:p>
-          <a:p>
-            <a:pPr>
-              <a:spcAft>
-                <a:spcPts val="1200"/>
-              </a:spcAft>
-              <a:defRPr sz="1800">
-                <a:solidFill>
-                  <a:srgbClr val="333333"/>
-                </a:solidFill>
-                <a:latin typeface="Microsoft YaHei"/>
-              </a:defRPr>
-            </a:pPr>
-            <a:r>
-              <a:t>2025/2026学费：£41,000；2027学费待公布（Not yet published）</a:t>
-            </a:r>
-          </a:p>
-          <a:p>
-            <a:pPr>
-              <a:spcAft>
-                <a:spcPts val="1200"/>
-              </a:spcAft>
-              <a:defRPr sz="1800">
-                <a:solidFill>
-                  <a:srgbClr val="333333"/>
-                </a:solidFill>
-                <a:latin typeface="Microsoft YaHei"/>
-              </a:defRPr>
-            </a:pPr>
-            <a:r>
-              <a:t>就业表现：约90%毕业生三个月内就业，主要雇主包括Amazon、Deloitte等</a:t>
+              <a:t>学历：UK一等或2:1，专业须为管理科学、运筹学、统计、计量经济、数学、物理、计算机、工程等含显著量化成分的学科</a:t>
+            </a:r>
+          </a:p>
+          <a:p>
+            <a:pPr>
+              <a:spcAft>
+                <a:spcPts val="1200"/>
+              </a:spcAft>
+              <a:defRPr sz="1800">
+                <a:solidFill>
+                  <a:srgbClr val="333333"/>
+                </a:solidFill>
+                <a:latin typeface="Microsoft YaHei"/>
+              </a:defRPr>
+            </a:pPr>
+            <a:r>
+              <a:t>中国申请者：均分85%以上，且本科院校须在爱大『Priority List of Chinese universities』的Band A名单内——重要硬门槛</a:t>
+            </a:r>
+          </a:p>
+          <a:p>
+            <a:pPr>
+              <a:spcAft>
+                <a:spcPts val="1200"/>
+              </a:spcAft>
+              <a:defRPr sz="1800">
+                <a:solidFill>
+                  <a:srgbClr val="333333"/>
+                </a:solidFill>
+                <a:latin typeface="Microsoft YaHei"/>
+              </a:defRPr>
+            </a:pPr>
+            <a:r>
+              <a:t>语言：雅思7.0（单项不低于6.0）——四校中单项要求最宽松</a:t>
+            </a:r>
+          </a:p>
+          <a:p>
+            <a:pPr>
+              <a:spcAft>
+                <a:spcPts val="1200"/>
+              </a:spcAft>
+              <a:defRPr sz="1800">
+                <a:solidFill>
+                  <a:srgbClr val="333333"/>
+                </a:solidFill>
+                <a:latin typeface="Microsoft YaHei"/>
+              </a:defRPr>
+            </a:pPr>
+            <a:r>
+              <a:t>GMAT/GRE：不强制，高分可增强竞争力</a:t>
+            </a:r>
+          </a:p>
+          <a:p>
+            <a:pPr>
+              <a:spcAft>
+                <a:spcPts val="1200"/>
+              </a:spcAft>
+              <a:defRPr sz="1800">
+                <a:solidFill>
+                  <a:srgbClr val="333333"/>
+                </a:solidFill>
+                <a:latin typeface="Microsoft YaHei"/>
+              </a:defRPr>
+            </a:pPr>
+            <a:r>
+              <a:t>录取机制：分轮录取（2026/27共5轮：第1轮2025年10月15日截止、第5轮2026年6月10日截止）；建议尽早递交</a:t>
             </a:r>
           </a:p>
         </p:txBody>
@@ -3866,7 +3863,7 @@
               </a:defRPr>
             </a:pPr>
             <a:r>
-              <a:t>UCL：课程结构与选修方向</a:t>
+              <a:t>选校第一步：评估自己的『硬基线』</a:t>
             </a:r>
           </a:p>
         </p:txBody>
@@ -3905,71 +3902,71 @@
               </a:defRPr>
             </a:pPr>
             <a:r>
-              <a:t>核心模块：共六门，涵盖统计方法、数据分析、运筹学、商业编程等</a:t>
-            </a:r>
-          </a:p>
-          <a:p>
-            <a:pPr>
-              <a:spcAft>
-                <a:spcPts val="1200"/>
-              </a:spcAft>
-              <a:defRPr sz="1800">
-                <a:solidFill>
-                  <a:srgbClr val="333333"/>
-                </a:solidFill>
-                <a:latin typeface="Microsoft YaHei"/>
-              </a:defRPr>
-            </a:pPr>
-            <a:r>
-              <a:t>选修模块：两门可选方向，聚焦市场分析或运营分析等领域</a:t>
-            </a:r>
-          </a:p>
-          <a:p>
-            <a:pPr>
-              <a:spcAft>
-                <a:spcPts val="1200"/>
-              </a:spcAft>
-              <a:defRPr sz="1800">
-                <a:solidFill>
-                  <a:srgbClr val="333333"/>
-                </a:solidFill>
-                <a:latin typeface="Microsoft YaHei"/>
-              </a:defRPr>
-            </a:pPr>
-            <a:r>
-              <a:t>结业项目：Dissertation项目，整合所学解决实际商业分析问题</a:t>
-            </a:r>
-          </a:p>
-          <a:p>
-            <a:pPr>
-              <a:spcAft>
-                <a:spcPts val="1200"/>
-              </a:spcAft>
-              <a:defRPr sz="1800">
-                <a:solidFill>
-                  <a:srgbClr val="333333"/>
-                </a:solidFill>
-                <a:latin typeface="Microsoft YaHei"/>
-              </a:defRPr>
-            </a:pPr>
-            <a:r>
-              <a:t>技能预期：入学前需具备Python或R等编程语言熟练度</a:t>
-            </a:r>
-          </a:p>
-          <a:p>
-            <a:pPr>
-              <a:spcAft>
-                <a:spcPts val="1200"/>
-              </a:spcAft>
-              <a:defRPr sz="1800">
-                <a:solidFill>
-                  <a:srgbClr val="333333"/>
-                </a:solidFill>
-                <a:latin typeface="Microsoft YaHei"/>
-              </a:defRPr>
-            </a:pPr>
-            <a:r>
-              <a:t>跨学科资源：可跨选UCL计算机、工程、经济学相关课程（视容量与许可）</a:t>
+              <a:t>量化三件套：微积分、线性代数、概率统计——四校共同关注的核心课程成绩</a:t>
+            </a:r>
+          </a:p>
+          <a:p>
+            <a:pPr>
+              <a:spcAft>
+                <a:spcPts val="1200"/>
+              </a:spcAft>
+              <a:defRPr sz="1800">
+                <a:solidFill>
+                  <a:srgbClr val="333333"/>
+                </a:solidFill>
+                <a:latin typeface="Microsoft YaHei"/>
+              </a:defRPr>
+            </a:pPr>
+            <a:r>
+              <a:t>GPA对照：爱丁堡明确要求中国申请者85%+（Band A名单院校）；IC/UCL/Warwick要求2:1等同学历（对应中国学历的具体要求以各校国际学历对照表为准）</a:t>
+            </a:r>
+          </a:p>
+          <a:p>
+            <a:pPr>
+              <a:spcAft>
+                <a:spcPts val="1200"/>
+              </a:spcAft>
+              <a:defRPr sz="1800">
+                <a:solidFill>
+                  <a:srgbClr val="333333"/>
+                </a:solidFill>
+                <a:latin typeface="Microsoft YaHei"/>
+              </a:defRPr>
+            </a:pPr>
+            <a:r>
+              <a:t>语言基线：雅思7.0是四校共同总分门槛；单项要求不同——IC/UCL 6.5、爱大6.0、华威Band B</a:t>
+            </a:r>
+          </a:p>
+          <a:p>
+            <a:pPr>
+              <a:spcAft>
+                <a:spcPts val="1200"/>
+              </a:spcAft>
+              <a:defRPr sz="1800">
+                <a:solidFill>
+                  <a:srgbClr val="333333"/>
+                </a:solidFill>
+                <a:latin typeface="Microsoft YaHei"/>
+              </a:defRPr>
+            </a:pPr>
+            <a:r>
+              <a:t>编程能力：SQL/R/Python至少精通一门；IC申请明确将编程经验列为加分项</a:t>
+            </a:r>
+          </a:p>
+          <a:p>
+            <a:pPr>
+              <a:spcAft>
+                <a:spcPts val="1200"/>
+              </a:spcAft>
+              <a:defRPr sz="1800">
+                <a:solidFill>
+                  <a:srgbClr val="333333"/>
+                </a:solidFill>
+                <a:latin typeface="Microsoft YaHei"/>
+              </a:defRPr>
+            </a:pPr>
+            <a:r>
+              <a:t>自评工具：用四校『量化经历陈述/数理要求』逐项打勾，识别短板并制定补强计划</a:t>
             </a:r>
           </a:p>
         </p:txBody>
@@ -4023,7 +4020,7 @@
               </a:defRPr>
             </a:pPr>
             <a:r>
-              <a:t>UCL：申请门槛与标化政策</a:t>
+              <a:t>选校第二步：职业目标 × 项目气质匹配</a:t>
             </a:r>
           </a:p>
         </p:txBody>
@@ -4062,71 +4059,71 @@
               </a:defRPr>
             </a:pPr>
             <a:r>
-              <a:t>学术要求：英制Upper Second Class（2:1）学士学位，要求强定量背景</a:t>
-            </a:r>
-          </a:p>
-          <a:p>
-            <a:pPr>
-              <a:spcAft>
-                <a:spcPts val="1200"/>
-              </a:spcAft>
-              <a:defRPr sz="1800">
-                <a:solidFill>
-                  <a:srgbClr val="333333"/>
-                </a:solidFill>
-                <a:latin typeface="Microsoft YaHei"/>
-              </a:defRPr>
-            </a:pPr>
-            <a:r>
-              <a:t>先修能力：数学或统计学基础扎实，熟练编程语言（Python/R）为隐性期望</a:t>
-            </a:r>
-          </a:p>
-          <a:p>
-            <a:pPr>
-              <a:spcAft>
-                <a:spcPts val="1200"/>
-              </a:spcAft>
-              <a:defRPr sz="1800">
-                <a:solidFill>
-                  <a:srgbClr val="333333"/>
-                </a:solidFill>
-                <a:latin typeface="Microsoft YaHei"/>
-              </a:defRPr>
-            </a:pPr>
-            <a:r>
-              <a:t>GMAT/GRE政策：官方未强制要求，跨专业或量化背景薄弱者可提交增强竞争力；2027最新政策To be verified</a:t>
-            </a:r>
-          </a:p>
-          <a:p>
-            <a:pPr>
-              <a:spcAft>
-                <a:spcPts val="1200"/>
-              </a:spcAft>
-              <a:defRPr sz="1800">
-                <a:solidFill>
-                  <a:srgbClr val="333333"/>
-                </a:solidFill>
-                <a:latin typeface="Microsoft YaHei"/>
-              </a:defRPr>
-            </a:pPr>
-            <a:r>
-              <a:t>语言成绩：雅思/托福必须达标；具体分数与豁免条件请参考UCL官方页面</a:t>
-            </a:r>
-          </a:p>
-          <a:p>
-            <a:pPr>
-              <a:spcAft>
-                <a:spcPts val="1200"/>
-              </a:spcAft>
-              <a:defRPr sz="1800">
-                <a:solidFill>
-                  <a:srgbClr val="333333"/>
-                </a:solidFill>
-                <a:latin typeface="Microsoft YaHei"/>
-              </a:defRPr>
-            </a:pPr>
-            <a:r>
-              <a:t>建议：即使非强制，高分标化仍能在滚动录取中提升竞争力</a:t>
+              <a:t>金融/咨询数据分析 → Imperial（行业实践强、Capstone咨询项目）或 UCL（金融区+咨询论文项目）</a:t>
+            </a:r>
+          </a:p>
+          <a:p>
+            <a:pPr>
+              <a:spcAft>
+                <a:spcPts val="1200"/>
+              </a:spcAft>
+              <a:defRPr sz="1800">
+                <a:solidFill>
+                  <a:srgbClr val="333333"/>
+                </a:solidFill>
+                <a:latin typeface="Microsoft YaHei"/>
+              </a:defRPr>
+            </a:pPr>
+            <a:r>
+              <a:t>AI/大数据技术方向 → UCL（机器学习/人工智能应用）或 Warwick（AI专业方向、深度学习与生成式AI）</a:t>
+            </a:r>
+          </a:p>
+          <a:p>
+            <a:pPr>
+              <a:spcAft>
+                <a:spcPts val="1200"/>
+              </a:spcAft>
+              <a:defRPr sz="1800">
+                <a:solidFill>
+                  <a:srgbClr val="333333"/>
+                </a:solidFill>
+                <a:latin typeface="Microsoft YaHei"/>
+              </a:defRPr>
+            </a:pPr>
+            <a:r>
+              <a:t>供应链/运筹/决策科学 → Warwick（管理分析方向、优化建模）或 Edinburgh（运筹学传统强）</a:t>
+            </a:r>
+          </a:p>
+          <a:p>
+            <a:pPr>
+              <a:spcAft>
+                <a:spcPts val="1200"/>
+              </a:spcAft>
+              <a:defRPr sz="1800">
+                <a:solidFill>
+                  <a:srgbClr val="333333"/>
+                </a:solidFill>
+                <a:latin typeface="Microsoft YaHei"/>
+              </a:defRPr>
+            </a:pPr>
+            <a:r>
+              <a:t>统计分析/计量研究 → Edinburgh（统计与计量基础扎实、课程偏学术严谨）</a:t>
+            </a:r>
+          </a:p>
+          <a:p>
+            <a:pPr>
+              <a:spcAft>
+                <a:spcPts val="1200"/>
+              </a:spcAft>
+              <a:defRPr sz="1800">
+                <a:solidFill>
+                  <a:srgbClr val="333333"/>
+                </a:solidFill>
+                <a:latin typeface="Microsoft YaHei"/>
+              </a:defRPr>
+            </a:pPr>
+            <a:r>
+              <a:t>行动建议：先写一段『5年职业叙事』，再反推哪个项目的课程与雇主网络最能支撑它</a:t>
             </a:r>
           </a:p>
         </p:txBody>
@@ -4180,7 +4177,7 @@
               </a:defRPr>
             </a:pPr>
             <a:r>
-              <a:t>UCL：差异化优势与适合人群</a:t>
+              <a:t>选校第三步：分层策略与成本测算</a:t>
             </a:r>
           </a:p>
         </p:txBody>
@@ -4219,71 +4216,55 @@
               </a:defRPr>
             </a:pPr>
             <a:r>
-              <a:t>综合排名：UCL在QS世界大学排名中稳居前列，综合声誉强</a:t>
-            </a:r>
-          </a:p>
-          <a:p>
-            <a:pPr>
-              <a:spcAft>
-                <a:spcPts val="1200"/>
-              </a:spcAft>
-              <a:defRPr sz="1800">
-                <a:solidFill>
-                  <a:srgbClr val="333333"/>
-                </a:solidFill>
-                <a:latin typeface="Microsoft YaHei"/>
-              </a:defRPr>
-            </a:pPr>
-            <a:r>
-              <a:t>地理位置：金丝雀码头校区位于伦敦新金融城，便于对接金融科技与咨询行业</a:t>
-            </a:r>
-          </a:p>
-          <a:p>
-            <a:pPr>
-              <a:spcAft>
-                <a:spcPts val="1200"/>
-              </a:spcAft>
-              <a:defRPr sz="1800">
-                <a:solidFill>
-                  <a:srgbClr val="333333"/>
-                </a:solidFill>
-                <a:latin typeface="Microsoft YaHei"/>
-              </a:defRPr>
-            </a:pPr>
-            <a:r>
-              <a:t>课程融合：管理与技术并重，适合希望兼顾商业领导力与技术分析的申请者</a:t>
-            </a:r>
-          </a:p>
-          <a:p>
-            <a:pPr>
-              <a:spcAft>
-                <a:spcPts val="1200"/>
-              </a:spcAft>
-              <a:defRPr sz="1800">
-                <a:solidFill>
-                  <a:srgbClr val="333333"/>
-                </a:solidFill>
-                <a:latin typeface="Microsoft YaHei"/>
-              </a:defRPr>
-            </a:pPr>
-            <a:r>
-              <a:t>就业网络：与Amazon、Deloitte等顶尖雇主保持密切校园招聘合作</a:t>
-            </a:r>
-          </a:p>
-          <a:p>
-            <a:pPr>
-              <a:spcAft>
-                <a:spcPts val="1200"/>
-              </a:spcAft>
-              <a:defRPr sz="1800">
-                <a:solidFill>
-                  <a:srgbClr val="333333"/>
-                </a:solidFill>
-                <a:latin typeface="Microsoft YaHei"/>
-              </a:defRPr>
-            </a:pPr>
-            <a:r>
-              <a:t>适合人群：本科具备定量基础，职业目标指向金融科技、互联网战略或咨询的申请者</a:t>
+              <a:t>分层策略：冲刺（Dream）约2所、主攻（Fit）2-3所、保底（Safety）约2所，总计6-8所；保底校录取概率须&gt;80%且『自己愿意去』</a:t>
+            </a:r>
+          </a:p>
+          <a:p>
+            <a:pPr>
+              <a:spcAft>
+                <a:spcPts val="1200"/>
+              </a:spcAft>
+              <a:defRPr sz="1800">
+                <a:solidFill>
+                  <a:srgbClr val="333333"/>
+                </a:solidFill>
+                <a:latin typeface="Microsoft YaHei"/>
+              </a:defRPr>
+            </a:pPr>
+            <a:r>
+              <a:t>成本测算：学费（2026年国际生口径）+生活费——伦敦（IC/UCL）显著高于华威与爱丁堡</a:t>
+            </a:r>
+          </a:p>
+          <a:p>
+            <a:pPr>
+              <a:spcAft>
+                <a:spcPts val="1200"/>
+              </a:spcAft>
+              <a:defRPr sz="1800">
+                <a:solidFill>
+                  <a:srgbClr val="333333"/>
+                </a:solidFill>
+                <a:latin typeface="Microsoft YaHei"/>
+              </a:defRPr>
+            </a:pPr>
+            <a:r>
+              <a:t>奖学金：IC最高£20,000（前两轮申请优先）、WBS奖学金池£150万+（学费10%-50%）、Chevening等政府奖学金</a:t>
+            </a:r>
+          </a:p>
+          <a:p>
+            <a:pPr>
+              <a:spcAft>
+                <a:spcPts val="1200"/>
+              </a:spcAft>
+              <a:defRPr sz="1800">
+                <a:solidFill>
+                  <a:srgbClr val="333333"/>
+                </a:solidFill>
+                <a:latin typeface="Microsoft YaHei"/>
+              </a:defRPr>
+            </a:pPr>
+            <a:r>
+              <a:t>决策提醒：冲刺校不超过3所；保底校宁可多申，不可形同虚设</a:t>
             </a:r>
           </a:p>
         </p:txBody>
@@ -4337,7 +4318,7 @@
               </a:defRPr>
             </a:pPr>
             <a:r>
-              <a:t>Warwick Business School：项目概览</a:t>
+              <a:t>准备重点①：学术硬实力，把量化地基打牢</a:t>
             </a:r>
           </a:p>
         </p:txBody>
@@ -4376,71 +4357,71 @@
               </a:defRPr>
             </a:pPr>
             <a:r>
-              <a:t>项目名称：MSc Business Analytics（全日制在校项目），区别于在线项目</a:t>
-            </a:r>
-          </a:p>
-          <a:p>
-            <a:pPr>
-              <a:spcAft>
-                <a:spcPts val="1200"/>
-              </a:spcAft>
-              <a:defRPr sz="1800">
-                <a:solidFill>
-                  <a:srgbClr val="333333"/>
-                </a:solidFill>
-                <a:latin typeface="Microsoft YaHei"/>
-              </a:defRPr>
-            </a:pPr>
-            <a:r>
-              <a:t>学制与地点：一年全日制，华威校区（Warwick Campus），2026/27学年9月入学</a:t>
-            </a:r>
-          </a:p>
-          <a:p>
-            <a:pPr>
-              <a:spcAft>
-                <a:spcPts val="1200"/>
-              </a:spcAft>
-              <a:defRPr sz="1800">
-                <a:solidFill>
-                  <a:srgbClr val="333333"/>
-                </a:solidFill>
-                <a:latin typeface="Microsoft YaHei"/>
-              </a:defRPr>
-            </a:pPr>
-            <a:r>
-              <a:t>课程结构：核心模块涵盖数据管理、预测分析、优化，并提供论文或实践项目双轨</a:t>
-            </a:r>
-          </a:p>
-          <a:p>
-            <a:pPr>
-              <a:spcAft>
-                <a:spcPts val="1200"/>
-              </a:spcAft>
-              <a:defRPr sz="1800">
-                <a:solidFill>
-                  <a:srgbClr val="333333"/>
-                </a:solidFill>
-                <a:latin typeface="Microsoft YaHei"/>
-              </a:defRPr>
-            </a:pPr>
-            <a:r>
-              <a:t>2025/2026学费：£37,450；2027学费Not yet published</a:t>
-            </a:r>
-          </a:p>
-          <a:p>
-            <a:pPr>
-              <a:spcAft>
-                <a:spcPts val="1200"/>
-              </a:spcAft>
-              <a:defRPr sz="1800">
-                <a:solidFill>
-                  <a:srgbClr val="333333"/>
-                </a:solidFill>
-                <a:latin typeface="Microsoft YaHei"/>
-              </a:defRPr>
-            </a:pPr>
-            <a:r>
-              <a:t>申请截止参考：2026/27 intake截止日期为2026年8月31日；2027截止日期待公布</a:t>
+              <a:t>核心课程成绩：微积分、线性代数、概率统计目标85+/90+，用成绩单证明量化能力</a:t>
+            </a:r>
+          </a:p>
+          <a:p>
+            <a:pPr>
+              <a:spcAft>
+                <a:spcPts val="1200"/>
+              </a:spcAft>
+              <a:defRPr sz="1800">
+                <a:solidFill>
+                  <a:srgbClr val="333333"/>
+                </a:solidFill>
+                <a:latin typeface="Microsoft YaHei"/>
+              </a:defRPr>
+            </a:pPr>
+            <a:r>
+              <a:t>编程补强：Python（pandas/numpy/scikit-learn）第一优先级，SQL其次，R可选——四校课程都会用到</a:t>
+            </a:r>
+          </a:p>
+          <a:p>
+            <a:pPr>
+              <a:spcAft>
+                <a:spcPts val="1200"/>
+              </a:spcAft>
+              <a:defRPr sz="1800">
+                <a:solidFill>
+                  <a:srgbClr val="333333"/>
+                </a:solidFill>
+                <a:latin typeface="Microsoft YaHei"/>
+              </a:defRPr>
+            </a:pPr>
+            <a:r>
+              <a:t>选课策略：仍有修课机会者优先选机器学习、运筹学、计量经济学、数据库等课程</a:t>
+            </a:r>
+          </a:p>
+          <a:p>
+            <a:pPr>
+              <a:spcAft>
+                <a:spcPts val="1200"/>
+              </a:spcAft>
+              <a:defRPr sz="1800">
+                <a:solidFill>
+                  <a:srgbClr val="333333"/>
+                </a:solidFill>
+                <a:latin typeface="Microsoft YaHei"/>
+              </a:defRPr>
+            </a:pPr>
+            <a:r>
+              <a:t>量化经历陈述（IC专属）：提前整理5门最高量化课程的清单与内容概要</a:t>
+            </a:r>
+          </a:p>
+          <a:p>
+            <a:pPr>
+              <a:spcAft>
+                <a:spcPts val="1200"/>
+              </a:spcAft>
+              <a:defRPr sz="1800">
+                <a:solidFill>
+                  <a:srgbClr val="333333"/>
+                </a:solidFill>
+                <a:latin typeface="Microsoft YaHei"/>
+              </a:defRPr>
+            </a:pPr>
+            <a:r>
+              <a:t>华威口径：官方要求『强数理、IT与统计能力』，本科成绩单与课程描述是核心证据</a:t>
             </a:r>
           </a:p>
         </p:txBody>
@@ -4494,7 +4475,7 @@
               </a:defRPr>
             </a:pPr>
             <a:r>
-              <a:t>Warwick：课程特色与申请门槛</a:t>
+              <a:t>准备重点②：标准化考试——语言与GMAT/GRE</a:t>
             </a:r>
           </a:p>
         </p:txBody>
@@ -4533,71 +4514,71 @@
               </a:defRPr>
             </a:pPr>
             <a:r>
-              <a:t>核心模块：数据管理、预测分析、优化模型、分析实践（Analytics in Practice）</a:t>
-            </a:r>
-          </a:p>
-          <a:p>
-            <a:pPr>
-              <a:spcAft>
-                <a:spcPts val="1200"/>
-              </a:spcAft>
-              <a:defRPr sz="1800">
-                <a:solidFill>
-                  <a:srgbClr val="333333"/>
-                </a:solidFill>
-                <a:latin typeface="Microsoft YaHei"/>
-              </a:defRPr>
-            </a:pPr>
-            <a:r>
-              <a:t>双轨结业：学术毕业论文（Academic Dissertation）或企业咨询项目（Practice-based Consultancy Project）</a:t>
-            </a:r>
-          </a:p>
-          <a:p>
-            <a:pPr>
-              <a:spcAft>
-                <a:spcPts val="1200"/>
-              </a:spcAft>
-              <a:defRPr sz="1800">
-                <a:solidFill>
-                  <a:srgbClr val="333333"/>
-                </a:solidFill>
-                <a:latin typeface="Microsoft YaHei"/>
-              </a:defRPr>
-            </a:pPr>
-            <a:r>
-              <a:t>学术要求：英制2:1本科学位，要求强定量能力</a:t>
-            </a:r>
-          </a:p>
-          <a:p>
-            <a:pPr>
-              <a:spcAft>
-                <a:spcPts val="1200"/>
-              </a:spcAft>
-              <a:defRPr sz="1800">
-                <a:solidFill>
-                  <a:srgbClr val="333333"/>
-                </a:solidFill>
-                <a:latin typeface="Microsoft YaHei"/>
-              </a:defRPr>
-            </a:pPr>
-            <a:r>
-              <a:t>标化考试：要求提交GMAT或GRE；典型GMAT期望分数约650-700</a:t>
-            </a:r>
-          </a:p>
-          <a:p>
-            <a:pPr>
-              <a:spcAft>
-                <a:spcPts val="1200"/>
-              </a:spcAft>
-              <a:defRPr sz="1800">
-                <a:solidFill>
-                  <a:srgbClr val="333333"/>
-                </a:solidFill>
-                <a:latin typeface="Microsoft YaHei"/>
-              </a:defRPr>
-            </a:pPr>
-            <a:r>
-              <a:t>语言要求：若非英语母语，需提供雅思或托福成绩</a:t>
+              <a:t>雅思：7.0是四校共同总分线；单项要求——IC/UCL 6.5、爱大6.0、华威Band B（两单项6.0/6.5+其余7.0）</a:t>
+            </a:r>
+          </a:p>
+          <a:p>
+            <a:pPr>
+              <a:spcAft>
+                <a:spcPts val="1200"/>
+              </a:spcAft>
+              <a:defRPr sz="1800">
+                <a:solidFill>
+                  <a:srgbClr val="333333"/>
+                </a:solidFill>
+                <a:latin typeface="Microsoft YaHei"/>
+              </a:defRPr>
+            </a:pPr>
+            <a:r>
+              <a:t>时间建议：申请季前（2026年秋）拿到达标成绩，为条件offer与签证留缓冲</a:t>
+            </a:r>
+          </a:p>
+          <a:p>
+            <a:pPr>
+              <a:spcAft>
+                <a:spcPts val="1200"/>
+              </a:spcAft>
+              <a:defRPr sz="1800">
+                <a:solidFill>
+                  <a:srgbClr val="333333"/>
+                </a:solidFill>
+                <a:latin typeface="Microsoft YaHei"/>
+              </a:defRPr>
+            </a:pPr>
+            <a:r>
+              <a:t>GMAT/GRE：IC非强制但量化背景弱时官方『强烈建议』（90分位）；UCL/Warwick/Edinburgh不要求</a:t>
+            </a:r>
+          </a:p>
+          <a:p>
+            <a:pPr>
+              <a:spcAft>
+                <a:spcPts val="1200"/>
+              </a:spcAft>
+              <a:defRPr sz="1800">
+                <a:solidFill>
+                  <a:srgbClr val="333333"/>
+                </a:solidFill>
+                <a:latin typeface="Microsoft YaHei"/>
+              </a:defRPr>
+            </a:pPr>
+            <a:r>
+              <a:t>决策原则：语言优先于G类；GPA与量化课程强，G类可不考或晚考；GMAT 650+普遍被视为有竞争力（非官方门槛）</a:t>
+            </a:r>
+          </a:p>
+          <a:p>
+            <a:pPr>
+              <a:spcAft>
+                <a:spcPts val="1200"/>
+              </a:spcAft>
+              <a:defRPr sz="1800">
+                <a:solidFill>
+                  <a:srgbClr val="333333"/>
+                </a:solidFill>
+                <a:latin typeface="Microsoft YaHei"/>
+              </a:defRPr>
+            </a:pPr>
+            <a:r>
+              <a:t>提醒：TOEFL部分院校已启用2026年1月21日后的新版评分（如IC总分5.0、爱大总分5.0），报名前确认各校接受版本</a:t>
             </a:r>
           </a:p>
         </p:txBody>
@@ -4651,7 +4632,7 @@
               </a:defRPr>
             </a:pPr>
             <a:r>
-              <a:t>Warwick：差异化优势与选校提示</a:t>
+              <a:t>准备重点③：软性背景——用项目证明『能落地』</a:t>
             </a:r>
           </a:p>
         </p:txBody>
@@ -4690,71 +4671,71 @@
               </a:defRPr>
             </a:pPr>
             <a:r>
-              <a:t>运营与战略传统：WBS在供应链、运营分析与战略咨询领域研究深厚</a:t>
-            </a:r>
-          </a:p>
-          <a:p>
-            <a:pPr>
-              <a:spcAft>
-                <a:spcPts val="1200"/>
-              </a:spcAft>
-              <a:defRPr sz="1800">
-                <a:solidFill>
-                  <a:srgbClr val="333333"/>
-                </a:solidFill>
-                <a:latin typeface="Microsoft YaHei"/>
-              </a:defRPr>
-            </a:pPr>
-            <a:r>
-              <a:t>咨询输送管道：毕业生广泛进入咨询行业，项目设计强调商业落地</a:t>
-            </a:r>
-          </a:p>
-          <a:p>
-            <a:pPr>
-              <a:spcAft>
-                <a:spcPts val="1200"/>
-              </a:spcAft>
-              <a:defRPr sz="1800">
-                <a:solidFill>
-                  <a:srgbClr val="333333"/>
-                </a:solidFill>
-                <a:latin typeface="Microsoft YaHei"/>
-              </a:defRPr>
-            </a:pPr>
-            <a:r>
-              <a:t>相对成本优势：学费与生活成本低于伦敦校区项目</a:t>
-            </a:r>
-          </a:p>
-          <a:p>
-            <a:pPr>
-              <a:spcAft>
-                <a:spcPts val="1200"/>
-              </a:spcAft>
-              <a:defRPr sz="1800">
-                <a:solidFill>
-                  <a:srgbClr val="333333"/>
-                </a:solidFill>
-                <a:latin typeface="Microsoft YaHei"/>
-              </a:defRPr>
-            </a:pPr>
-            <a:r>
-              <a:t>申请时间弹性：截止日期相对较晚（参考2026年为8月31日），但仍建议尽早提交</a:t>
-            </a:r>
-          </a:p>
-          <a:p>
-            <a:pPr>
-              <a:spcAft>
-                <a:spcPts val="1200"/>
-              </a:spcAft>
-              <a:defRPr sz="1800">
-                <a:solidFill>
-                  <a:srgbClr val="333333"/>
-                </a:solidFill>
-                <a:latin typeface="Microsoft YaHei"/>
-              </a:defRPr>
-            </a:pPr>
-            <a:r>
-              <a:t>适合人群：希望深耕运营分析、战略咨询，偏好校园沉浸式学习环境者</a:t>
+              <a:t>量化实习：数据分析/商业分析/市场分析岗至少1段，优先级最高的软性经历</a:t>
+            </a:r>
+          </a:p>
+          <a:p>
+            <a:pPr>
+              <a:spcAft>
+                <a:spcPts val="1200"/>
+              </a:spcAft>
+              <a:defRPr sz="1800">
+                <a:solidFill>
+                  <a:srgbClr val="333333"/>
+                </a:solidFill>
+                <a:latin typeface="Microsoft YaHei"/>
+              </a:defRPr>
+            </a:pPr>
+            <a:r>
+              <a:t>科研与课程项目：体现『数据清洗→建模→可视化→商业建议』完整流程的项目最有说服力</a:t>
+            </a:r>
+          </a:p>
+          <a:p>
+            <a:pPr>
+              <a:spcAft>
+                <a:spcPts val="1200"/>
+              </a:spcAft>
+              <a:defRPr sz="1800">
+                <a:solidFill>
+                  <a:srgbClr val="333333"/>
+                </a:solidFill>
+                <a:latin typeface="Microsoft YaHei"/>
+              </a:defRPr>
+            </a:pPr>
+            <a:r>
+              <a:t>数据竞赛：Kaggle、华为杯、数学建模等，既是简历亮点也是文书素材</a:t>
+            </a:r>
+          </a:p>
+          <a:p>
+            <a:pPr>
+              <a:spcAft>
+                <a:spcPts val="1200"/>
+              </a:spcAft>
+              <a:defRPr sz="1800">
+                <a:solidFill>
+                  <a:srgbClr val="333333"/>
+                </a:solidFill>
+                <a:latin typeface="Microsoft YaHei"/>
+              </a:defRPr>
+            </a:pPr>
+            <a:r>
+              <a:t>行业认知：积累目标行业（金融/咨询/零售）案例，文书与面试都需要</a:t>
+            </a:r>
+          </a:p>
+          <a:p>
+            <a:pPr>
+              <a:spcAft>
+                <a:spcPts val="1200"/>
+              </a:spcAft>
+              <a:defRPr sz="1800">
+                <a:solidFill>
+                  <a:srgbClr val="333333"/>
+                </a:solidFill>
+                <a:latin typeface="Microsoft YaHei"/>
+              </a:defRPr>
+            </a:pPr>
+            <a:r>
+              <a:t>关键原则：经历不在多，而在于能讲出『问题-方法-结果-商业影响』的完整故事</a:t>
             </a:r>
           </a:p>
         </p:txBody>
@@ -4808,7 +4789,7 @@
               </a:defRPr>
             </a:pPr>
             <a:r>
-              <a:t>演讲议程与重要声明</a:t>
+              <a:t>什么是商业分析硕士？——用数据驱动商业决策</a:t>
             </a:r>
           </a:p>
         </p:txBody>
@@ -4847,71 +4828,71 @@
               </a:defRPr>
             </a:pPr>
             <a:r>
-              <a:t>结构预览：学科认知 → 四校深度解析 → 选校框架 → 申请准备 → 时间线 → 风险提示</a:t>
-            </a:r>
-          </a:p>
-          <a:p>
-            <a:pPr>
-              <a:spcAft>
-                <a:spcPts val="1200"/>
-              </a:spcAft>
-              <a:defRPr sz="1800">
-                <a:solidFill>
-                  <a:srgbClr val="333333"/>
-                </a:solidFill>
-                <a:latin typeface="Microsoft YaHei"/>
-              </a:defRPr>
-            </a:pPr>
-            <a:r>
-              <a:t>目标受众：计划申请英国商业分析（Business Analytics）硕士的中国学生</a:t>
-            </a:r>
-          </a:p>
-          <a:p>
-            <a:pPr>
-              <a:spcAft>
-                <a:spcPts val="1200"/>
-              </a:spcAft>
-              <a:defRPr sz="1800">
-                <a:solidFill>
-                  <a:srgbClr val="333333"/>
-                </a:solidFill>
-                <a:latin typeface="Microsoft YaHei"/>
-              </a:defRPr>
-            </a:pPr>
-            <a:r>
-              <a:t>四校聚焦：Imperial、UCL、Warwick、Edinburgh</a:t>
-            </a:r>
-          </a:p>
-          <a:p>
-            <a:pPr>
-              <a:spcAft>
-                <a:spcPts val="1200"/>
-              </a:spcAft>
-              <a:defRPr sz="1800">
-                <a:solidFill>
-                  <a:srgbClr val="333333"/>
-                </a:solidFill>
-                <a:latin typeface="Microsoft YaHei"/>
-              </a:defRPr>
-            </a:pPr>
-            <a:r>
-              <a:t>免责声明：2027 Fall 尚未公布的轮次、截止日期、学费及文书题需以未来官方更新为准</a:t>
-            </a:r>
-          </a:p>
-          <a:p>
-            <a:pPr>
-              <a:spcAft>
-                <a:spcPts val="1200"/>
-              </a:spcAft>
-              <a:defRPr sz="1800">
-                <a:solidFill>
-                  <a:srgbClr val="333333"/>
-                </a:solidFill>
-                <a:latin typeface="Microsoft YaHei"/>
-              </a:defRPr>
-            </a:pPr>
-            <a:r>
-              <a:t>所有标注“Not yet published”的信息均待学校官网确认</a:t>
+              <a:t>商业分析（Business Analytics）：融合统计学、计算机科学与商科知识，将数据转化为商业洞察与决策的交叉学科</a:t>
+            </a:r>
+          </a:p>
+          <a:p>
+            <a:pPr>
+              <a:spcAft>
+                <a:spcPts val="1200"/>
+              </a:spcAft>
+              <a:defRPr sz="1800">
+                <a:solidFill>
+                  <a:srgbClr val="333333"/>
+                </a:solidFill>
+                <a:latin typeface="Microsoft YaHei"/>
+              </a:defRPr>
+            </a:pPr>
+            <a:r>
+              <a:t>核心课程模块：数据库与SQL、Python/R编程、数据挖掘、数据可视化、优化与决策模型、机器学习基础</a:t>
+            </a:r>
+          </a:p>
+          <a:p>
+            <a:pPr>
+              <a:spcAft>
+                <a:spcPts val="1200"/>
+              </a:spcAft>
+              <a:defRPr sz="1800">
+                <a:solidFill>
+                  <a:srgbClr val="333333"/>
+                </a:solidFill>
+                <a:latin typeface="Microsoft YaHei"/>
+              </a:defRPr>
+            </a:pPr>
+            <a:r>
+              <a:t>与数据科学硕士的区别：BA更强调『商业问题→数据分析→决策落地』，DS更侧重算法与模型本身</a:t>
+            </a:r>
+          </a:p>
+          <a:p>
+            <a:pPr>
+              <a:spcAft>
+                <a:spcPts val="1200"/>
+              </a:spcAft>
+              <a:defRPr sz="1800">
+                <a:solidFill>
+                  <a:srgbClr val="333333"/>
+                </a:solidFill>
+                <a:latin typeface="Microsoft YaHei"/>
+              </a:defRPr>
+            </a:pPr>
+            <a:r>
+              <a:t>与纯商科硕士的区别：BA对量化与编程有硬性门槛，课程以技术+商业双主线展开</a:t>
+            </a:r>
+          </a:p>
+          <a:p>
+            <a:pPr>
+              <a:spcAft>
+                <a:spcPts val="1200"/>
+              </a:spcAft>
+              <a:defRPr sz="1800">
+                <a:solidFill>
+                  <a:srgbClr val="333333"/>
+                </a:solidFill>
+                <a:latin typeface="Microsoft YaHei"/>
+              </a:defRPr>
+            </a:pPr>
+            <a:r>
+              <a:t>英国BA硕士特色：一年制授课型、学制紧凑、性价比高，普遍设置行业/咨询实践项目（如帝国理工夏季Capstone）</a:t>
             </a:r>
           </a:p>
         </p:txBody>
@@ -4965,7 +4946,7 @@
               </a:defRPr>
             </a:pPr>
             <a:r>
-              <a:t>University of Edinburgh：项目概览</a:t>
+              <a:t>准备重点④：文书与推荐信——讲好申请叙事</a:t>
             </a:r>
           </a:p>
         </p:txBody>
@@ -5004,71 +4985,71 @@
               </a:defRPr>
             </a:pPr>
             <a:r>
-              <a:t>项目名称：MSc Business Analytics，爱丁堡大学商学院（University of Edinburgh Business School）</a:t>
-            </a:r>
-          </a:p>
-          <a:p>
-            <a:pPr>
-              <a:spcAft>
-                <a:spcPts val="1200"/>
-              </a:spcAft>
-              <a:defRPr sz="1800">
-                <a:solidFill>
-                  <a:srgbClr val="333333"/>
-                </a:solidFill>
-                <a:latin typeface="Microsoft YaHei"/>
-              </a:defRPr>
-            </a:pPr>
-            <a:r>
-              <a:t>学制与地点：一年全日制，苏格兰爱丁堡校区</a:t>
-            </a:r>
-          </a:p>
-          <a:p>
-            <a:pPr>
-              <a:spcAft>
-                <a:spcPts val="1200"/>
-              </a:spcAft>
-              <a:defRPr sz="1800">
-                <a:solidFill>
-                  <a:srgbClr val="333333"/>
-                </a:solidFill>
-                <a:latin typeface="Microsoft YaHei"/>
-              </a:defRPr>
-            </a:pPr>
-            <a:r>
-              <a:t>课程结构：核心模块涵盖预测分析、规范分析、数据挖掘，必修毕业论文（Dissertation）</a:t>
-            </a:r>
-          </a:p>
-          <a:p>
-            <a:pPr>
-              <a:spcAft>
-                <a:spcPts val="1200"/>
-              </a:spcAft>
-              <a:defRPr sz="1800">
-                <a:solidFill>
-                  <a:srgbClr val="333333"/>
-                </a:solidFill>
-                <a:latin typeface="Microsoft YaHei"/>
-              </a:defRPr>
-            </a:pPr>
-            <a:r>
-              <a:t>2025/2026学费：£34,800；预估年生活费约£18,504；录取后需缴纳押金£2,500</a:t>
-            </a:r>
-          </a:p>
-          <a:p>
-            <a:pPr>
-              <a:spcAft>
-                <a:spcPts val="1200"/>
-              </a:spcAft>
-              <a:defRPr sz="1800">
-                <a:solidFill>
-                  <a:srgbClr val="333333"/>
-                </a:solidFill>
-                <a:latin typeface="Microsoft YaHei"/>
-              </a:defRPr>
-            </a:pPr>
-            <a:r>
-              <a:t>2027学费与生活费：Not yet published，将随官方更新调整</a:t>
+              <a:t>CV：一页为限，量化技能与商业成果前置，用数字量化成就</a:t>
+            </a:r>
+          </a:p>
+          <a:p>
+            <a:pPr>
+              <a:spcAft>
+                <a:spcPts val="1200"/>
+              </a:spcAft>
+              <a:defRPr sz="1800">
+                <a:solidFill>
+                  <a:srgbClr val="333333"/>
+                </a:solidFill>
+                <a:latin typeface="Microsoft YaHei"/>
+              </a:defRPr>
+            </a:pPr>
+            <a:r>
+              <a:t>个人陈述：三层叙事——Why BA → Why This Programme → Why You；引用具体课程与项目名称</a:t>
+            </a:r>
+          </a:p>
+          <a:p>
+            <a:pPr>
+              <a:spcAft>
+                <a:spcPts val="1200"/>
+              </a:spcAft>
+              <a:defRPr sz="1800">
+                <a:solidFill>
+                  <a:srgbClr val="333333"/>
+                </a:solidFill>
+                <a:latin typeface="Microsoft YaHei"/>
+              </a:defRPr>
+            </a:pPr>
+            <a:r>
+              <a:t>IC文书：三道essay题（职业规划350词、Why Imperial 500词、价值观事例500词）</a:t>
+            </a:r>
+          </a:p>
+          <a:p>
+            <a:pPr>
+              <a:spcAft>
+                <a:spcPts val="1200"/>
+              </a:spcAft>
+              <a:defRPr sz="1800">
+                <a:solidFill>
+                  <a:srgbClr val="333333"/>
+                </a:solidFill>
+                <a:latin typeface="Microsoft YaHei"/>
+              </a:defRPr>
+            </a:pPr>
+            <a:r>
+              <a:t>UCL文书：重点写清背景如何匹配课程要求、毕业目标如何被项目支持</a:t>
+            </a:r>
+          </a:p>
+          <a:p>
+            <a:pPr>
+              <a:spcAft>
+                <a:spcPts val="1200"/>
+              </a:spcAft>
+              <a:defRPr sz="1800">
+                <a:solidFill>
+                  <a:srgbClr val="333333"/>
+                </a:solidFill>
+                <a:latin typeface="Microsoft YaHei"/>
+              </a:defRPr>
+            </a:pPr>
+            <a:r>
+              <a:t>推荐信：2封，首选熟悉你数学/编程表现的学术推荐人；IC要求学术或『学术+职业』组合，且不接受个人邮箱（Gmail等）</a:t>
             </a:r>
           </a:p>
         </p:txBody>
@@ -5122,7 +5103,7 @@
               </a:defRPr>
             </a:pPr>
             <a:r>
-              <a:t>Edinburgh：申请门槛与标化政策</a:t>
+              <a:t>时间线·阶段一&amp;二：认知、语言与标准化考试</a:t>
             </a:r>
           </a:p>
         </p:txBody>
@@ -5161,71 +5142,55 @@
               </a:defRPr>
             </a:pPr>
             <a:r>
-              <a:t>学术要求：英制2:1荣誉学位，且须为定量学科（quantitative field）</a:t>
-            </a:r>
-          </a:p>
-          <a:p>
-            <a:pPr>
-              <a:spcAft>
-                <a:spcPts val="1200"/>
-              </a:spcAft>
-              <a:defRPr sz="1800">
-                <a:solidFill>
-                  <a:srgbClr val="333333"/>
-                </a:solidFill>
-                <a:latin typeface="Microsoft YaHei"/>
-              </a:defRPr>
-            </a:pPr>
-            <a:r>
-              <a:t>先修课程：要求本科阶段修读过统计学及计算机编程相关课程</a:t>
-            </a:r>
-          </a:p>
-          <a:p>
-            <a:pPr>
-              <a:spcAft>
-                <a:spcPts val="1200"/>
-              </a:spcAft>
-              <a:defRPr sz="1800">
-                <a:solidFill>
-                  <a:srgbClr val="333333"/>
-                </a:solidFill>
-                <a:latin typeface="Microsoft YaHei"/>
-              </a:defRPr>
-            </a:pPr>
-            <a:r>
-              <a:t>Band要求：爱丁堡商学院对中国院校设有Band List，录取标准因院校档次而异</a:t>
-            </a:r>
-          </a:p>
-          <a:p>
-            <a:pPr>
-              <a:spcAft>
-                <a:spcPts val="1200"/>
-              </a:spcAft>
-              <a:defRPr sz="1800">
-                <a:solidFill>
-                  <a:srgbClr val="333333"/>
-                </a:solidFill>
-                <a:latin typeface="Microsoft YaHei"/>
-              </a:defRPr>
-            </a:pPr>
-            <a:r>
-              <a:t>GMAT/GRE：不强制要求，无需提交</a:t>
-            </a:r>
-          </a:p>
-          <a:p>
-            <a:pPr>
-              <a:spcAft>
-                <a:spcPts val="1200"/>
-              </a:spcAft>
-              <a:defRPr sz="1800">
-                <a:solidFill>
-                  <a:srgbClr val="333333"/>
-                </a:solidFill>
-                <a:latin typeface="Microsoft YaHei"/>
-              </a:defRPr>
-            </a:pPr>
-            <a:r>
-              <a:t>语言要求：英语成绩有效期因考试类型而异（多数两年，部分三年半）；英语国家学位可能豁免</a:t>
+              <a:t>阶段一（2025.3-2025.8，理想节奏；若2026年年中启动则压缩合并）：确定冲刺/主攻/保底清单，考出语言目标分，启动第一段量化实习或科研</a:t>
+            </a:r>
+          </a:p>
+          <a:p>
+            <a:pPr>
+              <a:spcAft>
+                <a:spcPts val="1200"/>
+              </a:spcAft>
+              <a:defRPr sz="1800">
+                <a:solidFill>
+                  <a:srgbClr val="333333"/>
+                </a:solidFill>
+                <a:latin typeface="Microsoft YaHei"/>
+              </a:defRPr>
+            </a:pPr>
+            <a:r>
+              <a:t>阶段二（2025.9-2026.4）：GMAT/GRE备考与首考；补齐Python/SQL；整理量化课程清单与项目作品集；初步构思文书大纲与职业叙事</a:t>
+            </a:r>
+          </a:p>
+          <a:p>
+            <a:pPr>
+              <a:spcAft>
+                <a:spcPts val="1200"/>
+              </a:spcAft>
+              <a:defRPr sz="1800">
+                <a:solidFill>
+                  <a:srgbClr val="333333"/>
+                </a:solidFill>
+                <a:latin typeface="Microsoft YaHei"/>
+              </a:defRPr>
+            </a:pPr>
+            <a:r>
+              <a:t>里程碑：语言达标、G类有可用成绩、简历初版完成后再进入申请季</a:t>
+            </a:r>
+          </a:p>
+          <a:p>
+            <a:pPr>
+              <a:spcAft>
+                <a:spcPts val="1200"/>
+              </a:spcAft>
+              <a:defRPr sz="1800">
+                <a:solidFill>
+                  <a:srgbClr val="333333"/>
+                </a:solidFill>
+                <a:latin typeface="Microsoft YaHei"/>
+              </a:defRPr>
+            </a:pPr>
+            <a:r>
+              <a:t>提醒：2027入学各校开放与截止日期尚未公布，本时间线以2026周期已公布节奏为参考；越早启动越从容</a:t>
             </a:r>
           </a:p>
         </p:txBody>
@@ -5279,7 +5244,7 @@
               </a:defRPr>
             </a:pPr>
             <a:r>
-              <a:t>Edinburgh：差异化优势与适合人群</a:t>
+              <a:t>时间线·阶段三&amp;四：材料准备与第一轮递交</a:t>
             </a:r>
           </a:p>
         </p:txBody>
@@ -5318,71 +5283,55 @@
               </a:defRPr>
             </a:pPr>
             <a:r>
-              <a:t>研究导向：课程与学院研究强项结合，适合有意继续攻读博士或从事研究型岗位的申请者</a:t>
-            </a:r>
-          </a:p>
-          <a:p>
-            <a:pPr>
-              <a:spcAft>
-                <a:spcPts val="1200"/>
-              </a:spcAft>
-              <a:defRPr sz="1800">
-                <a:solidFill>
-                  <a:srgbClr val="333333"/>
-                </a:solidFill>
-                <a:latin typeface="Microsoft YaHei"/>
-              </a:defRPr>
-            </a:pPr>
-            <a:r>
-              <a:t>苏格兰生态：爱丁堡在金融科技（FinTech）与数据分析领域有本地就业生态</a:t>
-            </a:r>
-          </a:p>
-          <a:p>
-            <a:pPr>
-              <a:spcAft>
-                <a:spcPts val="1200"/>
-              </a:spcAft>
-              <a:defRPr sz="1800">
-                <a:solidFill>
-                  <a:srgbClr val="333333"/>
-                </a:solidFill>
-                <a:latin typeface="Microsoft YaHei"/>
-              </a:defRPr>
-            </a:pPr>
-            <a:r>
-              <a:t>班级规模与师生比：相对适中的班级规模有利于获得教授关注与学术指导</a:t>
-            </a:r>
-          </a:p>
-          <a:p>
-            <a:pPr>
-              <a:spcAft>
-                <a:spcPts val="1200"/>
-              </a:spcAft>
-              <a:defRPr sz="1800">
-                <a:solidFill>
-                  <a:srgbClr val="333333"/>
-                </a:solidFill>
-                <a:latin typeface="Microsoft YaHei"/>
-              </a:defRPr>
-            </a:pPr>
-            <a:r>
-              <a:t>成本优势：学费与生活成本在伦敦之外具备明显性价比</a:t>
-            </a:r>
-          </a:p>
-          <a:p>
-            <a:pPr>
-              <a:spcAft>
-                <a:spcPts val="1200"/>
-              </a:spcAft>
-              <a:defRPr sz="1800">
-                <a:solidFill>
-                  <a:srgbClr val="333333"/>
-                </a:solidFill>
-                <a:latin typeface="Microsoft YaHei"/>
-              </a:defRPr>
-            </a:pPr>
-            <a:r>
-              <a:t>适合人群：本科定量背景扎实、偏好学术氛围、希望控制留学预算或探索苏格兰就业机会者</a:t>
+              <a:t>阶段三（2026.5-2026.8）：准备成绩单/在读证明；联系2位推荐人并提前发出请求；打磨CV</a:t>
+            </a:r>
+          </a:p>
+          <a:p>
+            <a:pPr>
+              <a:spcAft>
+                <a:spcPts val="1200"/>
+              </a:spcAft>
+              <a:defRPr sz="1800">
+                <a:solidFill>
+                  <a:srgbClr val="333333"/>
+                </a:solidFill>
+                <a:latin typeface="Microsoft YaHei"/>
+              </a:defRPr>
+            </a:pPr>
+            <a:r>
+              <a:t>阶段四（2026.9-2026.12）：完成PS/essay初稿并多轮修改；递交第一轮申请（参考2026周期：IC第1轮9月底截止、UCL 10月中旬开放、爱大第1轮10月中旬截止）</a:t>
+            </a:r>
+          </a:p>
+          <a:p>
+            <a:pPr>
+              <a:spcAft>
+                <a:spcPts val="1200"/>
+              </a:spcAft>
+              <a:defRPr sz="1800">
+                <a:solidFill>
+                  <a:srgbClr val="333333"/>
+                </a:solidFill>
+                <a:latin typeface="Microsoft YaHei"/>
+              </a:defRPr>
+            </a:pPr>
+            <a:r>
+              <a:t>奖学金窗口：IC奖学金在第1、2轮递交者中优先评选——早递交即早锁定机会</a:t>
+            </a:r>
+          </a:p>
+          <a:p>
+            <a:pPr>
+              <a:spcAft>
+                <a:spcPts val="1200"/>
+              </a:spcAft>
+              <a:defRPr sz="1800">
+                <a:solidFill>
+                  <a:srgbClr val="333333"/>
+                </a:solidFill>
+                <a:latin typeface="Microsoft YaHei"/>
+              </a:defRPr>
+            </a:pPr>
+            <a:r>
+              <a:t>策略提示：第一轮递交竞争相对小、决策快，是性价比最高的申请窗口</a:t>
             </a:r>
           </a:p>
         </p:txBody>
@@ -5436,7 +5385,7 @@
               </a:defRPr>
             </a:pPr>
             <a:r>
-              <a:t>四校对比矩阵</a:t>
+              <a:t>时间线·阶段五&amp;六：等待结果与行前准备</a:t>
             </a:r>
           </a:p>
         </p:txBody>
@@ -5475,71 +5424,55 @@
               </a:defRPr>
             </a:pPr>
             <a:r>
-              <a:t>课程量化强度：Imperial ≈ UCL &gt; Warwick ≈ Edinburgh（均高强度，侧重不同）</a:t>
-            </a:r>
-          </a:p>
-          <a:p>
-            <a:pPr>
-              <a:spcAft>
-                <a:spcPts val="1200"/>
-              </a:spcAft>
-              <a:defRPr sz="1800">
-                <a:solidFill>
-                  <a:srgbClr val="333333"/>
-                </a:solidFill>
-                <a:latin typeface="Microsoft YaHei"/>
-              </a:defRPr>
-            </a:pPr>
-            <a:r>
-              <a:t>地理位置：Imperial / UCL（伦敦金融城资源） vs Warwick（华威校园） vs Edinburgh（苏格兰首府）</a:t>
-            </a:r>
-          </a:p>
-          <a:p>
-            <a:pPr>
-              <a:spcAft>
-                <a:spcPts val="1200"/>
-              </a:spcAft>
-              <a:defRPr sz="1800">
-                <a:solidFill>
-                  <a:srgbClr val="333333"/>
-                </a:solidFill>
-                <a:latin typeface="Microsoft YaHei"/>
-              </a:defRPr>
-            </a:pPr>
-            <a:r>
-              <a:t>学费区间（2025/26参考）：Imperial £47,000 &gt; UCL £41,000 &gt; Warwick £37,450 &gt; Edinburgh £34,800</a:t>
-            </a:r>
-          </a:p>
-          <a:p>
-            <a:pPr>
-              <a:spcAft>
-                <a:spcPts val="1200"/>
-              </a:spcAft>
-              <a:defRPr sz="1800">
-                <a:solidFill>
-                  <a:srgbClr val="333333"/>
-                </a:solidFill>
-                <a:latin typeface="Microsoft YaHei"/>
-              </a:defRPr>
-            </a:pPr>
-            <a:r>
-              <a:t>GMAT/GRE：Warwick（要求）；Imperial（强烈建议）；UCL（不强制，可补充）；Edinburgh（不要求）</a:t>
-            </a:r>
-          </a:p>
-          <a:p>
-            <a:pPr>
-              <a:spcAft>
-                <a:spcPts val="1200"/>
-              </a:spcAft>
-              <a:defRPr sz="1800">
-                <a:solidFill>
-                  <a:srgbClr val="333333"/>
-                </a:solidFill>
-                <a:latin typeface="Microsoft YaHei"/>
-              </a:defRPr>
-            </a:pPr>
-            <a:r>
-              <a:t>就业侧重：Imperial/UCL偏向金融科技与咨询；Warwick强调运营与战略；Edinburgh注重研究方法</a:t>
+              <a:t>阶段五（2027.1-2027.4）：跟进申请状态；面试模拟与准备；陆续收到offer并横向比较</a:t>
+            </a:r>
+          </a:p>
+          <a:p>
+            <a:pPr>
+              <a:spcAft>
+                <a:spcPts val="1200"/>
+              </a:spcAft>
+              <a:defRPr sz="1800">
+                <a:solidFill>
+                  <a:srgbClr val="333333"/>
+                </a:solidFill>
+                <a:latin typeface="Microsoft YaHei"/>
+              </a:defRPr>
+            </a:pPr>
+            <a:r>
+              <a:t>阶段六（2027.4-2027.8）：确认offer并缴纳押金（IC押金£6,500）；申请宿舍；准备资金证明与CAS；递交学生签证（关注UKVI审理时长）</a:t>
+            </a:r>
+          </a:p>
+          <a:p>
+            <a:pPr>
+              <a:spcAft>
+                <a:spcPts val="1200"/>
+              </a:spcAft>
+              <a:defRPr sz="1800">
+                <a:solidFill>
+                  <a:srgbClr val="333333"/>
+                </a:solidFill>
+                <a:latin typeface="Microsoft YaHei"/>
+              </a:defRPr>
+            </a:pPr>
+            <a:r>
+              <a:t>决策工具：拿到多个offer后，用『课程匹配度+就业数据+总成本』三表比较</a:t>
+            </a:r>
+          </a:p>
+          <a:p>
+            <a:pPr>
+              <a:spcAft>
+                <a:spcPts val="1200"/>
+              </a:spcAft>
+              <a:defRPr sz="1800">
+                <a:solidFill>
+                  <a:srgbClr val="333333"/>
+                </a:solidFill>
+                <a:latin typeface="Microsoft YaHei"/>
+              </a:defRPr>
+            </a:pPr>
+            <a:r>
+              <a:t>政策提醒：2027年1月起毕业生签证缩至18个月（非博士），留英求职与回国求职须并行规划</a:t>
             </a:r>
           </a:p>
         </p:txBody>
@@ -5593,7 +5526,7 @@
               </a:defRPr>
             </a:pPr>
             <a:r>
-              <a:t>选校框架三步法</a:t>
+              <a:t>风险与应对①：信息与竞争风险</a:t>
             </a:r>
           </a:p>
         </p:txBody>
@@ -5632,71 +5565,71 @@
               </a:defRPr>
             </a:pPr>
             <a:r>
-              <a:t>第一步：职业目标匹配 —— 明确留英/回国、目标行业（金融/咨询/科技/供应链）</a:t>
-            </a:r>
-          </a:p>
-          <a:p>
-            <a:pPr>
-              <a:spcAft>
-                <a:spcPts val="1200"/>
-              </a:spcAft>
-              <a:defRPr sz="1800">
-                <a:solidFill>
-                  <a:srgbClr val="333333"/>
-                </a:solidFill>
-                <a:latin typeface="Microsoft YaHei"/>
-              </a:defRPr>
-            </a:pPr>
-            <a:r>
-              <a:t>第二步：学术背景适配 —— 评估本科定量课程比重、编程熟练度、GPA与Band List位置</a:t>
-            </a:r>
-          </a:p>
-          <a:p>
-            <a:pPr>
-              <a:spcAft>
-                <a:spcPts val="1200"/>
-              </a:spcAft>
-              <a:defRPr sz="1800">
-                <a:solidFill>
-                  <a:srgbClr val="333333"/>
-                </a:solidFill>
-                <a:latin typeface="Microsoft YaHei"/>
-              </a:defRPr>
-            </a:pPr>
-            <a:r>
-              <a:t>第三步：预算与生活方式偏好 —— 权衡伦敦高成本+高资源 vs 非伦敦地区的性价比与沉浸感</a:t>
-            </a:r>
-          </a:p>
-          <a:p>
-            <a:pPr>
-              <a:spcAft>
-                <a:spcPts val="1200"/>
-              </a:spcAft>
-              <a:defRPr sz="1800">
-                <a:solidFill>
-                  <a:srgbClr val="333333"/>
-                </a:solidFill>
-                <a:latin typeface="Microsoft YaHei"/>
-              </a:defRPr>
-            </a:pPr>
-            <a:r>
-              <a:t>Imperial/UCL：优先推荐给职业目标明确指向伦敦金融/科技/咨询且预算充足者</a:t>
-            </a:r>
-          </a:p>
-          <a:p>
-            <a:pPr>
-              <a:spcAft>
-                <a:spcPts val="1200"/>
-              </a:spcAft>
-              <a:defRPr sz="1800">
-                <a:solidFill>
-                  <a:srgbClr val="333333"/>
-                </a:solidFill>
-                <a:latin typeface="Microsoft YaHei"/>
-              </a:defRPr>
-            </a:pPr>
-            <a:r>
-              <a:t>Warwick：推荐给重视运营战略、咨询路径，或需要更灵活申请时间线者</a:t>
+              <a:t>信息变更风险：2027年学费、要求、截止日期均未公布——所有数字以官网最新为准，建议每月复查一次各校页面</a:t>
+            </a:r>
+          </a:p>
+          <a:p>
+            <a:pPr>
+              <a:spcAft>
+                <a:spcPts val="1200"/>
+              </a:spcAft>
+              <a:defRPr sz="1800">
+                <a:solidFill>
+                  <a:srgbClr val="333333"/>
+                </a:solidFill>
+                <a:latin typeface="Microsoft YaHei"/>
+              </a:defRPr>
+            </a:pPr>
+            <a:r>
+              <a:t>项目更名风险：IC与Warwick的BA项目2026年起已更名/升级为『BA &amp; AI』，2027年课程结构可能继续调整，以官方programme页为准</a:t>
+            </a:r>
+          </a:p>
+          <a:p>
+            <a:pPr>
+              <a:spcAft>
+                <a:spcPts val="1200"/>
+              </a:spcAft>
+              <a:defRPr sz="1800">
+                <a:solidFill>
+                  <a:srgbClr val="333333"/>
+                </a:solidFill>
+                <a:latin typeface="Microsoft YaHei"/>
+              </a:defRPr>
+            </a:pPr>
+            <a:r>
+              <a:t>竞争加剧：BA申请量持续走高；GPA与G类成绩是硬通货，提前递交是现实策略</a:t>
+            </a:r>
+          </a:p>
+          <a:p>
+            <a:pPr>
+              <a:spcAft>
+                <a:spcPts val="1200"/>
+              </a:spcAft>
+              <a:defRPr sz="1800">
+                <a:solidFill>
+                  <a:srgbClr val="333333"/>
+                </a:solidFill>
+                <a:latin typeface="Microsoft YaHei"/>
+              </a:defRPr>
+            </a:pPr>
+            <a:r>
+              <a:t>保底失衡：保底校录取概率须&gt;80%，且『保底校必须是自己愿意去的』</a:t>
+            </a:r>
+          </a:p>
+          <a:p>
+            <a:pPr>
+              <a:spcAft>
+                <a:spcPts val="1200"/>
+              </a:spcAft>
+              <a:defRPr sz="1800">
+                <a:solidFill>
+                  <a:srgbClr val="333333"/>
+                </a:solidFill>
+                <a:latin typeface="Microsoft YaHei"/>
+              </a:defRPr>
+            </a:pPr>
+            <a:r>
+              <a:t>语言未达标预案：提前锁定考位避免裸考；未达标可考虑pre-sessional语言班（如爱大提供）</a:t>
             </a:r>
           </a:p>
         </p:txBody>
@@ -5750,7 +5683,7 @@
               </a:defRPr>
             </a:pPr>
             <a:r>
-              <a:t>申请准备（一）：学术先修与标化考试</a:t>
+              <a:t>风险与应对②：执行与资金风险</a:t>
             </a:r>
           </a:p>
         </p:txBody>
@@ -5789,71 +5722,71 @@
               </a:defRPr>
             </a:pPr>
             <a:r>
-              <a:t>学术先修：补齐统计学、微积分、线性代数；可通过Coursera/edX证书或本校选修课证明</a:t>
-            </a:r>
-          </a:p>
-          <a:p>
-            <a:pPr>
-              <a:spcAft>
-                <a:spcPts val="1200"/>
-              </a:spcAft>
-              <a:defRPr sz="1800">
-                <a:solidFill>
-                  <a:srgbClr val="333333"/>
-                </a:solidFill>
-                <a:latin typeface="Microsoft YaHei"/>
-              </a:defRPr>
-            </a:pPr>
-            <a:r>
-              <a:t>编程能力：掌握Python、R、SQL至少两种，建议有GitHub代码仓库或课程项目佐证</a:t>
-            </a:r>
-          </a:p>
-          <a:p>
-            <a:pPr>
-              <a:spcAft>
-                <a:spcPts val="1200"/>
-              </a:spcAft>
-              <a:defRPr sz="1800">
-                <a:solidFill>
-                  <a:srgbClr val="333333"/>
-                </a:solidFill>
-                <a:latin typeface="Microsoft YaHei"/>
-              </a:defRPr>
-            </a:pPr>
-            <a:r>
-              <a:t>语言考试：雅思总分通常要求7.0（单项不低于6.5）或托福等价；部分情况可豁免（如英语国家学位）</a:t>
-            </a:r>
-          </a:p>
-          <a:p>
-            <a:pPr>
-              <a:spcAft>
-                <a:spcPts val="1200"/>
-              </a:spcAft>
-              <a:defRPr sz="1800">
-                <a:solidFill>
-                  <a:srgbClr val="333333"/>
-                </a:solidFill>
-                <a:latin typeface="Microsoft YaHei"/>
-              </a:defRPr>
-            </a:pPr>
-            <a:r>
-              <a:t>GMAT/GRE策略：Warwick申请者必须备考；Imperial申请者强烈建议提交（目标GMAT 600+/GRE Q159+）；UCL/Edinburgh不强制</a:t>
-            </a:r>
-          </a:p>
-          <a:p>
-            <a:pPr>
-              <a:spcAft>
-                <a:spcPts val="1200"/>
-              </a:spcAft>
-              <a:defRPr sz="1800">
-                <a:solidFill>
-                  <a:srgbClr val="333333"/>
-                </a:solidFill>
-                <a:latin typeface="Microsoft YaHei"/>
-              </a:defRPr>
-            </a:pPr>
-            <a:r>
-              <a:t>时间建议：2026年3-8月完成所有标化考试，为9月网申开放预留刷分与送分时间</a:t>
+              <a:t>推荐人拖延/失联：提前2-3个月沟通并定期提醒，准备备选推荐人；IC明确不接受个人邮箱（Gmail/Hotmail等）推荐</a:t>
+            </a:r>
+          </a:p>
+          <a:p>
+            <a:pPr>
+              <a:spcAft>
+                <a:spcPts val="1200"/>
+              </a:spcAft>
+              <a:defRPr sz="1800">
+                <a:solidFill>
+                  <a:srgbClr val="333333"/>
+                </a:solidFill>
+                <a:latin typeface="Microsoft YaHei"/>
+              </a:defRPr>
+            </a:pPr>
+            <a:r>
+              <a:t>文书同质化：避免模板化陈述，用具体课程、项目经历与职业目标建立独特性</a:t>
+            </a:r>
+          </a:p>
+          <a:p>
+            <a:pPr>
+              <a:spcAft>
+                <a:spcPts val="1200"/>
+              </a:spcAft>
+              <a:defRPr sz="1800">
+                <a:solidFill>
+                  <a:srgbClr val="333333"/>
+                </a:solidFill>
+                <a:latin typeface="Microsoft YaHei"/>
+              </a:defRPr>
+            </a:pPr>
+            <a:r>
+              <a:t>资金证明：按『学费+生活费』提前准备存款，关注UKVI资金证明要求变化</a:t>
+            </a:r>
+          </a:p>
+          <a:p>
+            <a:pPr>
+              <a:spcAft>
+                <a:spcPts val="1200"/>
+              </a:spcAft>
+              <a:defRPr sz="1800">
+                <a:solidFill>
+                  <a:srgbClr val="333333"/>
+                </a:solidFill>
+                <a:latin typeface="Microsoft YaHei"/>
+              </a:defRPr>
+            </a:pPr>
+            <a:r>
+              <a:t>签证节奏：2027届毕业时毕业生签证仅18个月，求职窗口变短——实习与求职要更早启动</a:t>
+            </a:r>
+          </a:p>
+          <a:p>
+            <a:pPr>
+              <a:spcAft>
+                <a:spcPts val="1200"/>
+              </a:spcAft>
+              <a:defRPr sz="1800">
+                <a:solidFill>
+                  <a:srgbClr val="333333"/>
+                </a:solidFill>
+                <a:latin typeface="Microsoft YaHei"/>
+              </a:defRPr>
+            </a:pPr>
+            <a:r>
+              <a:t>心态管理：申请是马拉松，早规划+持续复盘+保留Plan B</a:t>
             </a:r>
           </a:p>
         </p:txBody>
@@ -5907,7 +5840,7 @@
               </a:defRPr>
             </a:pPr>
             <a:r>
-              <a:t>申请准备（二）：软性背景与文书材料</a:t>
+              <a:t>总结：四校一句话记忆点</a:t>
             </a:r>
           </a:p>
         </p:txBody>
@@ -5946,71 +5879,39 @@
               </a:defRPr>
             </a:pPr>
             <a:r>
-              <a:t>实习经历：至少1-2段数据分析、战略咨询、金融科技或互联网商业分析相关实习</a:t>
-            </a:r>
-          </a:p>
-          <a:p>
-            <a:pPr>
-              <a:spcAft>
-                <a:spcPts val="1200"/>
-              </a:spcAft>
-              <a:defRPr sz="1800">
-                <a:solidFill>
-                  <a:srgbClr val="333333"/>
-                </a:solidFill>
-                <a:latin typeface="Microsoft YaHei"/>
-              </a:defRPr>
-            </a:pPr>
-            <a:r>
-              <a:t>项目经历：Kaggle竞赛、课程设计项目、独立数据分析报告，形成可展示的作品集</a:t>
-            </a:r>
-          </a:p>
-          <a:p>
-            <a:pPr>
-              <a:spcAft>
-                <a:spcPts val="1200"/>
-              </a:spcAft>
-              <a:defRPr sz="1800">
-                <a:solidFill>
-                  <a:srgbClr val="333333"/>
-                </a:solidFill>
-                <a:latin typeface="Microsoft YaHei"/>
-              </a:defRPr>
-            </a:pPr>
-            <a:r>
-              <a:t>简历（CV）：严格控制在1页以内，突出量化成果（如‘通过预测模型提升准确率X%’）</a:t>
-            </a:r>
-          </a:p>
-          <a:p>
-            <a:pPr>
-              <a:spcAft>
-                <a:spcPts val="1200"/>
-              </a:spcAft>
-              <a:defRPr sz="1800">
-                <a:solidFill>
-                  <a:srgbClr val="333333"/>
-                </a:solidFill>
-                <a:latin typeface="Microsoft YaHei"/>
-              </a:defRPr>
-            </a:pPr>
-            <a:r>
-              <a:t>文书（PS）：构建清晰的职业目标故事线，具体解释Why School（课程设置、Capstone、地理位置）</a:t>
-            </a:r>
-          </a:p>
-          <a:p>
-            <a:pPr>
-              <a:spcAft>
-                <a:spcPts val="1200"/>
-              </a:spcAft>
-              <a:defRPr sz="1800">
-                <a:solidFill>
-                  <a:srgbClr val="333333"/>
-                </a:solidFill>
-                <a:latin typeface="Microsoft YaHei"/>
-              </a:defRPr>
-            </a:pPr>
-            <a:r>
-              <a:t>推荐信：优先选择能证明你定量能力与商业洞察的教授或实习主管</a:t>
+              <a:t>四校记忆点：Imperial=行业实践+AI最强、学费最高（2026年£47,000）；UCL=金融区+咨询项目、竞争最激烈；Warwick=BA&amp;AI四大方向、供应链/运筹/营销全覆盖、奖学金池大；Edinburgh=运筹统计传统、有中国院校Band A门槛、成本最低</a:t>
+            </a:r>
+          </a:p>
+          <a:p>
+            <a:pPr>
+              <a:spcAft>
+                <a:spcPts val="1200"/>
+              </a:spcAft>
+              <a:defRPr sz="1800">
+                <a:solidFill>
+                  <a:srgbClr val="333333"/>
+                </a:solidFill>
+                <a:latin typeface="Microsoft YaHei"/>
+              </a:defRPr>
+            </a:pPr>
+            <a:r>
+              <a:t>选校公式：职业目标 × 量化背景 × 成本预算 × 地理偏好 = 最优解</a:t>
+            </a:r>
+          </a:p>
+          <a:p>
+            <a:pPr>
+              <a:spcAft>
+                <a:spcPts val="1200"/>
+              </a:spcAft>
+              <a:defRPr sz="1800">
+                <a:solidFill>
+                  <a:srgbClr val="333333"/>
+                </a:solidFill>
+                <a:latin typeface="Microsoft YaHei"/>
+              </a:defRPr>
+            </a:pPr>
+            <a:r>
+              <a:t>共同门槛：雅思7.0、2:1学历、量化基础——先把这三样做到位</a:t>
             </a:r>
           </a:p>
         </p:txBody>
@@ -6064,7 +5965,7 @@
               </a:defRPr>
             </a:pPr>
             <a:r>
-              <a:t>申请准备（三）：面试与时间线上半段</a:t>
+              <a:t>行动清单：现在就可以做的事</a:t>
             </a:r>
           </a:p>
         </p:txBody>
@@ -6103,385 +6004,71 @@
               </a:defRPr>
             </a:pPr>
             <a:r>
-              <a:t>面试类型：技术问题（统计概念、简单Case分析、编程思路）+ 行为面试（动机、职业规划、团队协作）</a:t>
-            </a:r>
-          </a:p>
-          <a:p>
-            <a:pPr>
-              <a:spcAft>
-                <a:spcPts val="1200"/>
-              </a:spcAft>
-              <a:defRPr sz="1800">
-                <a:solidFill>
-                  <a:srgbClr val="333333"/>
-                </a:solidFill>
-                <a:latin typeface="Microsoft YaHei"/>
-              </a:defRPr>
-            </a:pPr>
-            <a:r>
-              <a:t>技术准备：复习假设检验、回归分析、A/B测试原理；熟悉Python/R在业务场景的应用</a:t>
-            </a:r>
-          </a:p>
-          <a:p>
-            <a:pPr>
-              <a:spcAft>
-                <a:spcPts val="1200"/>
-              </a:spcAft>
-              <a:defRPr sz="1800">
-                <a:solidFill>
-                  <a:srgbClr val="333333"/>
-                </a:solidFill>
-                <a:latin typeface="Microsoft YaHei"/>
-              </a:defRPr>
-            </a:pPr>
-            <a:r>
-              <a:t>行为准备：用STAR法则描述过往项目经历，强调数据驱动的决策过程</a:t>
-            </a:r>
-          </a:p>
-          <a:p>
-            <a:pPr>
-              <a:spcAft>
-                <a:spcPts val="1200"/>
-              </a:spcAft>
-              <a:defRPr sz="1800">
-                <a:solidFill>
-                  <a:srgbClr val="333333"/>
-                </a:solidFill>
-                <a:latin typeface="Microsoft YaHei"/>
-              </a:defRPr>
-            </a:pPr>
-            <a:r>
-              <a:t>2026年3-8月任务清单：选校定位、标化考试出分、先修课收尾、积累实习与项目素材、联系校友了解项目细节</a:t>
-            </a:r>
-          </a:p>
-          <a:p>
-            <a:pPr>
-              <a:spcAft>
-                <a:spcPts val="1200"/>
-              </a:spcAft>
-              <a:defRPr sz="1800">
-                <a:solidFill>
-                  <a:srgbClr val="333333"/>
-                </a:solidFill>
-                <a:latin typeface="Microsoft YaHei"/>
-              </a:defRPr>
-            </a:pPr>
-            <a:r>
-              <a:t>信息核查：定期查看四校官网，订阅招生办邮件，获取2027 Fall最新动态</a:t>
-            </a:r>
-          </a:p>
-        </p:txBody>
-      </p:sp>
-    </p:spTree>
-  </p:cSld>
-  <p:clrMapOvr>
-    <a:masterClrMapping/>
-  </p:clrMapOvr>
-</p:sld>
-</file>
-
-<file path=ppt/slides/slide28.xml><?xml version="1.0" encoding="utf-8"?>
-<p:sld xmlns:a="http://schemas.openxmlformats.org/drawingml/2006/main" xmlns:p="http://schemas.openxmlformats.org/presentationml/2006/main" xmlns:r="http://schemas.openxmlformats.org/officeDocument/2006/relationships">
-  <p:cSld>
-    <p:spTree>
-      <p:nvGrpSpPr>
-        <p:cNvPr id="1" name=""/>
-        <p:cNvGrpSpPr/>
-        <p:nvPr/>
-      </p:nvGrpSpPr>
-      <p:grpSpPr/>
-      <p:sp>
-        <p:nvSpPr>
-          <p:cNvPr id="2" name="TextBox 1"/>
-          <p:cNvSpPr txBox="1"/>
-          <p:nvPr/>
-        </p:nvSpPr>
-        <p:spPr>
-          <a:xfrm>
-            <a:off x="731520" y="548640"/>
-            <a:ext cx="10728655" cy="914400"/>
-          </a:xfrm>
-          <a:prstGeom prst="rect">
-            <a:avLst/>
-          </a:prstGeom>
-          <a:noFill/>
-        </p:spPr>
-        <p:txBody>
-          <a:bodyPr wrap="none">
-            <a:spAutoFit/>
-          </a:bodyPr>
-          <a:lstStyle/>
-          <a:p>
-            <a:pPr>
-              <a:defRPr sz="3200" b="1">
-                <a:solidFill>
-                  <a:srgbClr val="1E3A5F"/>
-                </a:solidFill>
-                <a:latin typeface="Microsoft YaHei"/>
-              </a:defRPr>
-            </a:pPr>
-            <a:r>
-              <a:t>2027 Fall 完整申请时间线（下半段）</a:t>
-            </a:r>
-          </a:p>
-        </p:txBody>
-      </p:sp>
-      <p:sp>
-        <p:nvSpPr>
-          <p:cNvPr id="3" name="TextBox 2"/>
-          <p:cNvSpPr txBox="1"/>
-          <p:nvPr/>
-        </p:nvSpPr>
-        <p:spPr>
-          <a:xfrm>
-            <a:off x="731520" y="1645920"/>
-            <a:ext cx="10728655" cy="4572000"/>
-          </a:xfrm>
-          <a:prstGeom prst="rect">
-            <a:avLst/>
-          </a:prstGeom>
-          <a:noFill/>
-        </p:spPr>
-        <p:txBody>
-          <a:bodyPr wrap="square">
-            <a:spAutoFit/>
-          </a:bodyPr>
-          <a:lstStyle/>
-          <a:p>
-            <a:pPr>
-              <a:spcAft>
-                <a:spcPts val="1200"/>
-              </a:spcAft>
-              <a:defRPr sz="1800">
-                <a:solidFill>
-                  <a:srgbClr val="333333"/>
-                </a:solidFill>
-                <a:latin typeface="Microsoft YaHei"/>
-              </a:defRPr>
-            </a:pPr>
-            <a:r>
-              <a:t>2026年9-10月：网申系统开放（2027 intake），优先赶Round 1提交；准备成绩单、推荐信、文书</a:t>
-            </a:r>
-          </a:p>
-          <a:p>
-            <a:pPr>
-              <a:spcAft>
-                <a:spcPts val="1200"/>
-              </a:spcAft>
-              <a:defRPr sz="1800">
-                <a:solidFill>
-                  <a:srgbClr val="333333"/>
-                </a:solidFill>
-                <a:latin typeface="Microsoft YaHei"/>
-              </a:defRPr>
-            </a:pPr>
-            <a:r>
-              <a:t>2026年11月-2027年3月：接收面试邀请、补交材料、等待录取结果；部分项目可能滚动发放offer</a:t>
-            </a:r>
-          </a:p>
-          <a:p>
-            <a:pPr>
-              <a:spcAft>
-                <a:spcPts val="1200"/>
-              </a:spcAft>
-              <a:defRPr sz="1800">
-                <a:solidFill>
-                  <a:srgbClr val="333333"/>
-                </a:solidFill>
-                <a:latin typeface="Microsoft YaHei"/>
-              </a:defRPr>
-            </a:pPr>
-            <a:r>
-              <a:t>2027年4-7月：接受offer并支付押金（如爱丁堡要求£2,500）、换取CAS、申请学校宿舍或私人住宿</a:t>
-            </a:r>
-          </a:p>
-          <a:p>
-            <a:pPr>
-              <a:spcAft>
-                <a:spcPts val="1200"/>
-              </a:spcAft>
-              <a:defRPr sz="1800">
-                <a:solidFill>
-                  <a:srgbClr val="333333"/>
-                </a:solidFill>
-                <a:latin typeface="Microsoft YaHei"/>
-              </a:defRPr>
-            </a:pPr>
-            <a:r>
-              <a:t>2027年5-8月：办理学生签证（注意IHS医疗附加费与处理时长）、关注英镑汇率安排资金</a:t>
-            </a:r>
-          </a:p>
-          <a:p>
-            <a:pPr>
-              <a:spcAft>
-                <a:spcPts val="1200"/>
-              </a:spcAft>
-              <a:defRPr sz="1800">
-                <a:solidFill>
-                  <a:srgbClr val="333333"/>
-                </a:solidFill>
-                <a:latin typeface="Microsoft YaHei"/>
-              </a:defRPr>
-            </a:pPr>
-            <a:r>
-              <a:t>关键提示：2027 Fall具体截止日期、学费、文书题目均以2025年底至2026年官方更新为准；本时间线为基于历史规律的规划基准</a:t>
-            </a:r>
-          </a:p>
-        </p:txBody>
-      </p:sp>
-    </p:spTree>
-  </p:cSld>
-  <p:clrMapOvr>
-    <a:masterClrMapping/>
-  </p:clrMapOvr>
-</p:sld>
-</file>
-
-<file path=ppt/slides/slide29.xml><?xml version="1.0" encoding="utf-8"?>
-<p:sld xmlns:a="http://schemas.openxmlformats.org/drawingml/2006/main" xmlns:p="http://schemas.openxmlformats.org/presentationml/2006/main" xmlns:r="http://schemas.openxmlformats.org/officeDocument/2006/relationships">
-  <p:cSld>
-    <p:spTree>
-      <p:nvGrpSpPr>
-        <p:cNvPr id="1" name=""/>
-        <p:cNvGrpSpPr/>
-        <p:nvPr/>
-      </p:nvGrpSpPr>
-      <p:grpSpPr/>
-      <p:sp>
-        <p:nvSpPr>
-          <p:cNvPr id="2" name="TextBox 1"/>
-          <p:cNvSpPr txBox="1"/>
-          <p:nvPr/>
-        </p:nvSpPr>
-        <p:spPr>
-          <a:xfrm>
-            <a:off x="731520" y="548640"/>
-            <a:ext cx="10728655" cy="914400"/>
-          </a:xfrm>
-          <a:prstGeom prst="rect">
-            <a:avLst/>
-          </a:prstGeom>
-          <a:noFill/>
-        </p:spPr>
-        <p:txBody>
-          <a:bodyPr wrap="none">
-            <a:spAutoFit/>
-          </a:bodyPr>
-          <a:lstStyle/>
-          <a:p>
-            <a:pPr>
-              <a:defRPr sz="3200" b="1">
-                <a:solidFill>
-                  <a:srgbClr val="1E3A5F"/>
-                </a:solidFill>
-                <a:latin typeface="Microsoft YaHei"/>
-              </a:defRPr>
-            </a:pPr>
-            <a:r>
-              <a:t>风险提示与应对策略</a:t>
-            </a:r>
-          </a:p>
-        </p:txBody>
-      </p:sp>
-      <p:sp>
-        <p:nvSpPr>
-          <p:cNvPr id="3" name="TextBox 2"/>
-          <p:cNvSpPr txBox="1"/>
-          <p:nvPr/>
-        </p:nvSpPr>
-        <p:spPr>
-          <a:xfrm>
-            <a:off x="731520" y="1645920"/>
-            <a:ext cx="10728655" cy="4572000"/>
-          </a:xfrm>
-          <a:prstGeom prst="rect">
-            <a:avLst/>
-          </a:prstGeom>
-          <a:noFill/>
-        </p:spPr>
-        <p:txBody>
-          <a:bodyPr wrap="square">
-            <a:spAutoFit/>
-          </a:bodyPr>
-          <a:lstStyle/>
-          <a:p>
-            <a:pPr>
-              <a:spcAft>
-                <a:spcPts val="1200"/>
-              </a:spcAft>
-              <a:defRPr sz="1800">
-                <a:solidFill>
-                  <a:srgbClr val="333333"/>
-                </a:solidFill>
-                <a:latin typeface="Microsoft YaHei"/>
-              </a:defRPr>
-            </a:pPr>
-            <a:r>
-              <a:t>名额风险：热门项目可能提前满员，强烈建议在前两轮（Round 1/2）完成投递</a:t>
-            </a:r>
-          </a:p>
-          <a:p>
-            <a:pPr>
-              <a:spcAft>
-                <a:spcPts val="1200"/>
-              </a:spcAft>
-              <a:defRPr sz="1800">
-                <a:solidFill>
-                  <a:srgbClr val="333333"/>
-                </a:solidFill>
-                <a:latin typeface="Microsoft YaHei"/>
-              </a:defRPr>
-            </a:pPr>
-            <a:r>
-              <a:t>信息风险：2027申请轮次、学费上涨幅度、语言政策变动尚未公布，需持续追踪官网与招生办邮件</a:t>
-            </a:r>
-          </a:p>
-          <a:p>
-            <a:pPr>
-              <a:spcAft>
-                <a:spcPts val="1200"/>
-              </a:spcAft>
-              <a:defRPr sz="1800">
-                <a:solidFill>
-                  <a:srgbClr val="333333"/>
-                </a:solidFill>
-                <a:latin typeface="Microsoft YaHei"/>
-              </a:defRPr>
-            </a:pPr>
-            <a:r>
-              <a:t>签证与资金：IHS医疗附加费可能调整，签证处理时长存在波动，建议预留至少3个月缓冲期；关注英镑汇率</a:t>
-            </a:r>
-          </a:p>
-          <a:p>
-            <a:pPr>
-              <a:spcAft>
-                <a:spcPts val="1200"/>
-              </a:spcAft>
-              <a:defRPr sz="1800">
-                <a:solidFill>
-                  <a:srgbClr val="333333"/>
-                </a:solidFill>
-                <a:latin typeface="Microsoft YaHei"/>
-              </a:defRPr>
-            </a:pPr>
-            <a:r>
-              <a:t>竞争加剧应对：若GPA或实习存在短板，可通过高标化成绩、额外在线证书、高质量作品集弥补</a:t>
-            </a:r>
-          </a:p>
-          <a:p>
-            <a:pPr>
-              <a:spcAft>
-                <a:spcPts val="1200"/>
-              </a:spcAft>
-              <a:defRPr sz="1800">
-                <a:solidFill>
-                  <a:srgbClr val="333333"/>
-                </a:solidFill>
-                <a:latin typeface="Microsoft YaHei"/>
-              </a:defRPr>
-            </a:pPr>
-            <a:r>
-              <a:t>混申保底：建议搭配1-2所录取概率更高的院校或相近项目（如MSc Data Science/Management）作为安全网</a:t>
+              <a:t>本月：建立四校官网收藏夹与信息追踪表（学费/截止/要求三列），每周更新一次</a:t>
+            </a:r>
+          </a:p>
+          <a:p>
+            <a:pPr>
+              <a:spcAft>
+                <a:spcPts val="1200"/>
+              </a:spcAft>
+              <a:defRPr sz="1800">
+                <a:solidFill>
+                  <a:srgbClr val="333333"/>
+                </a:solidFill>
+                <a:latin typeface="Microsoft YaHei"/>
+              </a:defRPr>
+            </a:pPr>
+            <a:r>
+              <a:t>未来3个月：锁定雅思考试日期并报名；梳理量化课程清单与作品集</a:t>
+            </a:r>
+          </a:p>
+          <a:p>
+            <a:pPr>
+              <a:spcAft>
+                <a:spcPts val="1200"/>
+              </a:spcAft>
+              <a:defRPr sz="1800">
+                <a:solidFill>
+                  <a:srgbClr val="333333"/>
+                </a:solidFill>
+                <a:latin typeface="Microsoft YaHei"/>
+              </a:defRPr>
+            </a:pPr>
+            <a:r>
+              <a:t>未来6个月：完成第一段量化实习或数据竞赛；做出GMAT/GRE决策</a:t>
+            </a:r>
+          </a:p>
+          <a:p>
+            <a:pPr>
+              <a:spcAft>
+                <a:spcPts val="1200"/>
+              </a:spcAft>
+              <a:defRPr sz="1800">
+                <a:solidFill>
+                  <a:srgbClr val="333333"/>
+                </a:solidFill>
+                <a:latin typeface="Microsoft YaHei"/>
+              </a:defRPr>
+            </a:pPr>
+            <a:r>
+              <a:t>申请季前12个月：完成CV与文书初稿，力争第一轮递交</a:t>
+            </a:r>
+          </a:p>
+          <a:p>
+            <a:pPr>
+              <a:spcAft>
+                <a:spcPts val="1200"/>
+              </a:spcAft>
+              <a:defRPr sz="1800">
+                <a:solidFill>
+                  <a:srgbClr val="333333"/>
+                </a:solidFill>
+                <a:latin typeface="Microsoft YaHei"/>
+              </a:defRPr>
+            </a:pPr>
+            <a:r>
+              <a:t>最后提醒：所有信息以官方发布为准（2027年数据未公布时，不用往年数字猜测），保持耐心与积极心态</a:t>
             </a:r>
           </a:p>
         </p:txBody>
@@ -6535,7 +6122,7 @@
               </a:defRPr>
             </a:pPr>
             <a:r>
-              <a:t>商业分析硕士：学科定义</a:t>
+              <a:t>毕业去向：哪些行业在抢商业分析人才</a:t>
             </a:r>
           </a:p>
         </p:txBody>
@@ -6574,212 +6161,71 @@
               </a:defRPr>
             </a:pPr>
             <a:r>
-              <a:t>商业分析（Business Analytics）是商业、数据科学、统计学与计算机科学的交叉学科</a:t>
-            </a:r>
-          </a:p>
-          <a:p>
-            <a:pPr>
-              <a:spcAft>
-                <a:spcPts val="1200"/>
-              </a:spcAft>
-              <a:defRPr sz="1800">
-                <a:solidFill>
-                  <a:srgbClr val="333333"/>
-                </a:solidFill>
-                <a:latin typeface="Microsoft YaHei"/>
-              </a:defRPr>
-            </a:pPr>
-            <a:r>
-              <a:t>核心目标：通过数据驱动方法解决商业决策问题，将海量数据转化为可执行的商业洞察</a:t>
-            </a:r>
-          </a:p>
-          <a:p>
-            <a:pPr>
-              <a:spcAft>
-                <a:spcPts val="1200"/>
-              </a:spcAft>
-              <a:defRPr sz="1800">
-                <a:solidFill>
-                  <a:srgbClr val="333333"/>
-                </a:solidFill>
-                <a:latin typeface="Microsoft YaHei"/>
-              </a:defRPr>
-            </a:pPr>
-            <a:r>
-              <a:t>区别于纯数据科学：更强调商业场景落地、决策优化与战略价值</a:t>
-            </a:r>
-          </a:p>
-          <a:p>
-            <a:pPr>
-              <a:spcAft>
-                <a:spcPts val="1200"/>
-              </a:spcAft>
-              <a:defRPr sz="1800">
-                <a:solidFill>
-                  <a:srgbClr val="333333"/>
-                </a:solidFill>
-                <a:latin typeface="Microsoft YaHei"/>
-              </a:defRPr>
-            </a:pPr>
-            <a:r>
-              <a:t>区别于纯商科：要求扎实的量化分析能力与编程实现技能</a:t>
-            </a:r>
-          </a:p>
-        </p:txBody>
-      </p:sp>
-    </p:spTree>
-  </p:cSld>
-  <p:clrMapOvr>
-    <a:masterClrMapping/>
-  </p:clrMapOvr>
-</p:sld>
-</file>
-
-<file path=ppt/slides/slide30.xml><?xml version="1.0" encoding="utf-8"?>
-<p:sld xmlns:a="http://schemas.openxmlformats.org/drawingml/2006/main" xmlns:p="http://schemas.openxmlformats.org/presentationml/2006/main" xmlns:r="http://schemas.openxmlformats.org/officeDocument/2006/relationships">
-  <p:cSld>
-    <p:spTree>
-      <p:nvGrpSpPr>
-        <p:cNvPr id="1" name=""/>
-        <p:cNvGrpSpPr/>
-        <p:nvPr/>
-      </p:nvGrpSpPr>
-      <p:grpSpPr/>
-      <p:sp>
-        <p:nvSpPr>
-          <p:cNvPr id="2" name="TextBox 1"/>
-          <p:cNvSpPr txBox="1"/>
-          <p:nvPr/>
-        </p:nvSpPr>
-        <p:spPr>
-          <a:xfrm>
-            <a:off x="731520" y="548640"/>
-            <a:ext cx="10728655" cy="914400"/>
-          </a:xfrm>
-          <a:prstGeom prst="rect">
-            <a:avLst/>
-          </a:prstGeom>
-          <a:noFill/>
-        </p:spPr>
-        <p:txBody>
-          <a:bodyPr wrap="none">
-            <a:spAutoFit/>
-          </a:bodyPr>
-          <a:lstStyle/>
-          <a:p>
-            <a:pPr>
-              <a:defRPr sz="3200" b="1">
-                <a:solidFill>
-                  <a:srgbClr val="1E3A5F"/>
-                </a:solidFill>
-                <a:latin typeface="Microsoft YaHei"/>
-              </a:defRPr>
-            </a:pPr>
-            <a:r>
-              <a:t>结语与开放问答</a:t>
-            </a:r>
-          </a:p>
-        </p:txBody>
-      </p:sp>
-      <p:sp>
-        <p:nvSpPr>
-          <p:cNvPr id="3" name="TextBox 2"/>
-          <p:cNvSpPr txBox="1"/>
-          <p:nvPr/>
-        </p:nvSpPr>
-        <p:spPr>
-          <a:xfrm>
-            <a:off x="731520" y="1645920"/>
-            <a:ext cx="10728655" cy="4572000"/>
-          </a:xfrm>
-          <a:prstGeom prst="rect">
-            <a:avLst/>
-          </a:prstGeom>
-          <a:noFill/>
-        </p:spPr>
-        <p:txBody>
-          <a:bodyPr wrap="square">
-            <a:spAutoFit/>
-          </a:bodyPr>
-          <a:lstStyle/>
-          <a:p>
-            <a:pPr>
-              <a:spcAft>
-                <a:spcPts val="1200"/>
-              </a:spcAft>
-              <a:defRPr sz="1800">
-                <a:solidFill>
-                  <a:srgbClr val="333333"/>
-                </a:solidFill>
-                <a:latin typeface="Microsoft YaHei"/>
-              </a:defRPr>
-            </a:pPr>
-            <a:r>
-              <a:t>核心回顾：理解BA学科本质 → 横向对比Imperial/UCL/Warwick/Edinburgh → 制定个人选校策略 → 严格执行时间线</a:t>
-            </a:r>
-          </a:p>
-          <a:p>
-            <a:pPr>
-              <a:spcAft>
-                <a:spcPts val="1200"/>
-              </a:spcAft>
-              <a:defRPr sz="1800">
-                <a:solidFill>
-                  <a:srgbClr val="333333"/>
-                </a:solidFill>
-                <a:latin typeface="Microsoft YaHei"/>
-              </a:defRPr>
-            </a:pPr>
-            <a:r>
-              <a:t>即刻行动：今天就开始评估自身量化背景缺口，规划夏季实习或先修课程</a:t>
-            </a:r>
-          </a:p>
-          <a:p>
-            <a:pPr>
-              <a:spcAft>
-                <a:spcPts val="1200"/>
-              </a:spcAft>
-              <a:defRPr sz="1800">
-                <a:solidFill>
-                  <a:srgbClr val="333333"/>
-                </a:solidFill>
-                <a:latin typeface="Microsoft YaHei"/>
-              </a:defRPr>
-            </a:pPr>
-            <a:r>
-              <a:t>信息优先级：学校官网 &gt; 直接致信招生办 &gt; 在读学生一手分享 &gt; 第三方平台信息</a:t>
-            </a:r>
-          </a:p>
-          <a:p>
-            <a:pPr>
-              <a:spcAft>
-                <a:spcPts val="1200"/>
-              </a:spcAft>
-              <a:defRPr sz="1800">
-                <a:solidFill>
-                  <a:srgbClr val="333333"/>
-                </a:solidFill>
-                <a:latin typeface="Microsoft YaHei"/>
-              </a:defRPr>
-            </a:pPr>
-            <a:r>
-              <a:t>Q&amp;A：欢迎就个人背景评估、文书策略、面试准备与选校组合提出问题</a:t>
-            </a:r>
-          </a:p>
-          <a:p>
-            <a:pPr>
-              <a:spcAft>
-                <a:spcPts val="1200"/>
-              </a:spcAft>
-              <a:defRPr sz="1800">
-                <a:solidFill>
-                  <a:srgbClr val="333333"/>
-                </a:solidFill>
-                <a:latin typeface="Microsoft YaHei"/>
-              </a:defRPr>
-            </a:pPr>
-            <a:r>
-              <a:t>祝各位申请顺利，2027 Fall收获理想offer！</a:t>
+              <a:t>典型岗位：商业分析师、数据分析师、咨询顾问、金融科技分析师、数据产品经理</a:t>
+            </a:r>
+          </a:p>
+          <a:p>
+            <a:pPr>
+              <a:spcAft>
+                <a:spcPts val="1200"/>
+              </a:spcAft>
+              <a:defRPr sz="1800">
+                <a:solidFill>
+                  <a:srgbClr val="333333"/>
+                </a:solidFill>
+                <a:latin typeface="Microsoft YaHei"/>
+              </a:defRPr>
+            </a:pPr>
+            <a:r>
+              <a:t>覆盖行业：互联网、金融、零售、咨询、供应链、医疗健康、能源</a:t>
+            </a:r>
+          </a:p>
+          <a:p>
+            <a:pPr>
+              <a:spcAft>
+                <a:spcPts val="1200"/>
+              </a:spcAft>
+              <a:defRPr sz="1800">
+                <a:solidFill>
+                  <a:srgbClr val="333333"/>
+                </a:solidFill>
+                <a:latin typeface="Microsoft YaHei"/>
+              </a:defRPr>
+            </a:pPr>
+            <a:r>
+              <a:t>雇主画像：四大咨询（Accenture、EY、KPMG等）、投行与金融科技、科技大厂——华威往届雇主名单印证</a:t>
+            </a:r>
+          </a:p>
+          <a:p>
+            <a:pPr>
+              <a:spcAft>
+                <a:spcPts val="1200"/>
+              </a:spcAft>
+              <a:defRPr sz="1800">
+                <a:solidFill>
+                  <a:srgbClr val="333333"/>
+                </a:solidFill>
+                <a:latin typeface="Microsoft YaHei"/>
+              </a:defRPr>
+            </a:pPr>
+            <a:r>
+              <a:t>帝国理工官方数据：2024届毕业生95%在毕业后6个月内就业</a:t>
+            </a:r>
+          </a:p>
+          <a:p>
+            <a:pPr>
+              <a:spcAft>
+                <a:spcPts val="1200"/>
+              </a:spcAft>
+              <a:defRPr sz="1800">
+                <a:solidFill>
+                  <a:srgbClr val="333333"/>
+                </a:solidFill>
+                <a:latin typeface="Microsoft YaHei"/>
+              </a:defRPr>
+            </a:pPr>
+            <a:r>
+              <a:t>核心启示：雇主看重『能落地』的分析能力，实习与项目经历是简历和文书中的关键证据</a:t>
             </a:r>
           </a:p>
         </p:txBody>
@@ -6833,7 +6279,7 @@
               </a:defRPr>
             </a:pPr>
             <a:r>
-              <a:t>典型课程模块与技能栈</a:t>
+              <a:t>英国BA项目格局：声誉与排名的坐标系</a:t>
             </a:r>
           </a:p>
         </p:txBody>
@@ -6872,71 +6318,71 @@
               </a:defRPr>
             </a:pPr>
             <a:r>
-              <a:t>预测建模（Predictive Modeling）与机器学习（Machine Learning）</a:t>
-            </a:r>
-          </a:p>
-          <a:p>
-            <a:pPr>
-              <a:spcAft>
-                <a:spcPts val="1200"/>
-              </a:spcAft>
-              <a:defRPr sz="1800">
-                <a:solidFill>
-                  <a:srgbClr val="333333"/>
-                </a:solidFill>
-                <a:latin typeface="Microsoft YaHei"/>
-              </a:defRPr>
-            </a:pPr>
-            <a:r>
-              <a:t>运筹优化（Operations Research）与规范分析（Prescriptive Analytics）</a:t>
-            </a:r>
-          </a:p>
-          <a:p>
-            <a:pPr>
-              <a:spcAft>
-                <a:spcPts val="1200"/>
-              </a:spcAft>
-              <a:defRPr sz="1800">
-                <a:solidFill>
-                  <a:srgbClr val="333333"/>
-                </a:solidFill>
-                <a:latin typeface="Microsoft YaHei"/>
-              </a:defRPr>
-            </a:pPr>
-            <a:r>
-              <a:t>数据可视化（Data Visualization）与商业决策模拟</a:t>
-            </a:r>
-          </a:p>
-          <a:p>
-            <a:pPr>
-              <a:spcAft>
-                <a:spcPts val="1200"/>
-              </a:spcAft>
-              <a:defRPr sz="1800">
-                <a:solidFill>
-                  <a:srgbClr val="333333"/>
-                </a:solidFill>
-                <a:latin typeface="Microsoft YaHei"/>
-              </a:defRPr>
-            </a:pPr>
-            <a:r>
-              <a:t>数据库管理与编程：Python、R、SQL为核心工具</a:t>
-            </a:r>
-          </a:p>
-          <a:p>
-            <a:pPr>
-              <a:spcAft>
-                <a:spcPts val="1200"/>
-              </a:spcAft>
-              <a:defRPr sz="1800">
-                <a:solidFill>
-                  <a:srgbClr val="333333"/>
-                </a:solidFill>
-                <a:latin typeface="Microsoft YaHei"/>
-              </a:defRPr>
-            </a:pPr>
-            <a:r>
-              <a:t>帝国理工课程涵盖机器学习与预测分析，并设置企业实战项目（Capstone）</a:t>
+              <a:t>QS Business Masters Rankings（商业分析方向）2025英国入围：伦敦商学院全球第5、帝国理工第8、华威第17、曼大第20、爱丁堡第25</a:t>
+            </a:r>
+          </a:p>
+          <a:p>
+            <a:pPr>
+              <a:spcAft>
+                <a:spcPts val="1200"/>
+              </a:spcAft>
+              <a:defRPr sz="1800">
+                <a:solidFill>
+                  <a:srgbClr val="333333"/>
+                </a:solidFill>
+                <a:latin typeface="Microsoft YaHei"/>
+              </a:defRPr>
+            </a:pPr>
+            <a:r>
+              <a:t>帝国理工官方口径：QS 2026商业分析硕士全球第8、欧洲第4</a:t>
+            </a:r>
+          </a:p>
+          <a:p>
+            <a:pPr>
+              <a:spcAft>
+                <a:spcPts val="1200"/>
+              </a:spcAft>
+              <a:defRPr sz="1800">
+                <a:solidFill>
+                  <a:srgbClr val="333333"/>
+                </a:solidFill>
+                <a:latin typeface="Microsoft YaHei"/>
+              </a:defRPr>
+            </a:pPr>
+            <a:r>
+              <a:t>华威官方口径：QS 2026商业分析硕士全英第3、全球第13</a:t>
+            </a:r>
+          </a:p>
+          <a:p>
+            <a:pPr>
+              <a:spcAft>
+                <a:spcPts val="1200"/>
+              </a:spcAft>
+              <a:defRPr sz="1800">
+                <a:solidFill>
+                  <a:srgbClr val="333333"/>
+                </a:solidFill>
+                <a:latin typeface="Microsoft YaHei"/>
+              </a:defRPr>
+            </a:pPr>
+            <a:r>
+              <a:t>爱丁堡官方口径：QS 2026商业分析硕士全球第26</a:t>
+            </a:r>
+          </a:p>
+          <a:p>
+            <a:pPr>
+              <a:spcAft>
+                <a:spcPts val="1200"/>
+              </a:spcAft>
+              <a:defRPr sz="1800">
+                <a:solidFill>
+                  <a:srgbClr val="333333"/>
+                </a:solidFill>
+                <a:latin typeface="Microsoft YaHei"/>
+              </a:defRPr>
+            </a:pPr>
+            <a:r>
+              <a:t>启示：排名是坐标系而非结论，需叠加课程、就业报告与行业关系综合判断</a:t>
             </a:r>
           </a:p>
         </p:txBody>
@@ -6990,7 +6436,7 @@
               </a:defRPr>
             </a:pPr>
             <a:r>
-              <a:t>常见毕业去向与就业概览</a:t>
+              <a:t>项目类型与选校关键变量（含PSW重大更新）</a:t>
             </a:r>
           </a:p>
         </p:txBody>
@@ -7029,71 +6475,71 @@
               </a:defRPr>
             </a:pPr>
             <a:r>
-              <a:t>主要行业：咨询、金融科技（FinTech）、互联网产品/运营分析、零售供应链、风险与定价</a:t>
-            </a:r>
-          </a:p>
-          <a:p>
-            <a:pPr>
-              <a:spcAft>
-                <a:spcPts val="1200"/>
-              </a:spcAft>
-              <a:defRPr sz="1800">
-                <a:solidFill>
-                  <a:srgbClr val="333333"/>
-                </a:solidFill>
-                <a:latin typeface="Microsoft YaHei"/>
-              </a:defRPr>
-            </a:pPr>
-            <a:r>
-              <a:t>典型岗位：数据分析师、商业智能分析师、运营分析师、咨询顾问、风险分析师</a:t>
-            </a:r>
-          </a:p>
-          <a:p>
-            <a:pPr>
-              <a:spcAft>
-                <a:spcPts val="1200"/>
-              </a:spcAft>
-              <a:defRPr sz="1800">
-                <a:solidFill>
-                  <a:srgbClr val="333333"/>
-                </a:solidFill>
-                <a:latin typeface="Microsoft YaHei"/>
-              </a:defRPr>
-            </a:pPr>
-            <a:r>
-              <a:t>UCL就业报告：约90%的毕业生在三个月内就业，主要雇主包括Amazon与Deloitte</a:t>
-            </a:r>
-          </a:p>
-          <a:p>
-            <a:pPr>
-              <a:spcAft>
-                <a:spcPts val="1200"/>
-              </a:spcAft>
-              <a:defRPr sz="1800">
-                <a:solidFill>
-                  <a:srgbClr val="333333"/>
-                </a:solidFill>
-                <a:latin typeface="Microsoft YaHei"/>
-              </a:defRPr>
-            </a:pPr>
-            <a:r>
-              <a:t>留英路径：利用Graduate Route签证寻找Entry-Level分析师岗位；伦敦金融城资源集中</a:t>
-            </a:r>
-          </a:p>
-          <a:p>
-            <a:pPr>
-              <a:spcAft>
-                <a:spcPts val="1200"/>
-              </a:spcAft>
-              <a:defRPr sz="1800">
-                <a:solidFill>
-                  <a:srgbClr val="333333"/>
-                </a:solidFill>
-                <a:latin typeface="Microsoft YaHei"/>
-              </a:defRPr>
-            </a:pPr>
-            <a:r>
-              <a:t>回国路径：互联网大厂战略/商业分析、金融机构风控、外企咨询公司</a:t>
+              <a:t>独立BA项目 vs 数据科学/管理类项目：独立BA聚焦商业应用，DS偏技术；部分管理项目仅有BA选修方向</a:t>
+            </a:r>
+          </a:p>
+          <a:p>
+            <a:pPr>
+              <a:spcAft>
+                <a:spcPts val="1200"/>
+              </a:spcAft>
+              <a:defRPr sz="1800">
+                <a:solidFill>
+                  <a:srgbClr val="333333"/>
+                </a:solidFill>
+                <a:latin typeface="Microsoft YaHei"/>
+              </a:defRPr>
+            </a:pPr>
+            <a:r>
+              <a:t>关键选校变量：地理位置（伦敦vs非伦敦）、实习与行业资源、校友网络、就业报告、学费与奖学金</a:t>
+            </a:r>
+          </a:p>
+          <a:p>
+            <a:pPr>
+              <a:spcAft>
+                <a:spcPts val="1200"/>
+              </a:spcAft>
+              <a:defRPr sz="1800">
+                <a:solidFill>
+                  <a:srgbClr val="333333"/>
+                </a:solidFill>
+                <a:latin typeface="Microsoft YaHei"/>
+              </a:defRPr>
+            </a:pPr>
+            <a:r>
+              <a:t>伦敦：实习与networking密度高（UCL在Canary Wharf金融区、IC在South Kensington）；非伦敦：成本更低、校园体验更完整</a:t>
+            </a:r>
+          </a:p>
+          <a:p>
+            <a:pPr>
+              <a:spcAft>
+                <a:spcPts val="1200"/>
+              </a:spcAft>
+              <a:defRPr sz="1800">
+                <a:solidFill>
+                  <a:srgbClr val="333333"/>
+                </a:solidFill>
+                <a:latin typeface="Microsoft YaHei"/>
+              </a:defRPr>
+            </a:pPr>
+            <a:r>
+              <a:t>PSW重大更新：英国毕业生签证（Graduate Route）自2027年1月1日起，非博士毕业生停留期由2年缩短至18个月（博士仍3年）——2027秋入学学生毕业时适用新政，留英求职时间线须重新压缩</a:t>
+            </a:r>
+          </a:p>
+          <a:p>
+            <a:pPr>
+              <a:spcAft>
+                <a:spcPts val="1200"/>
+              </a:spcAft>
+              <a:defRPr sz="1800">
+                <a:solidFill>
+                  <a:srgbClr val="333333"/>
+                </a:solidFill>
+                <a:latin typeface="Microsoft YaHei"/>
+              </a:defRPr>
+            </a:pPr>
+            <a:r>
+              <a:t>政策依据：英国政府《Immigration Rules Statement of Changes HC 1333》（2025年10月14日发布）</a:t>
             </a:r>
           </a:p>
         </p:txBody>
@@ -7147,7 +6593,7 @@
               </a:defRPr>
             </a:pPr>
             <a:r>
-              <a:t>英国一年制硕士：优势与节奏</a:t>
+              <a:t>Imperial：MSc Business Analytics &amp; AI 项目概览</a:t>
             </a:r>
           </a:p>
         </p:txBody>
@@ -7186,71 +6632,71 @@
               </a:defRPr>
             </a:pPr>
             <a:r>
-              <a:t>时间效率：通常12个月完成学位，快速进入职场，节约时间与机会成本</a:t>
-            </a:r>
-          </a:p>
-          <a:p>
-            <a:pPr>
-              <a:spcAft>
-                <a:spcPts val="1200"/>
-              </a:spcAft>
-              <a:defRPr sz="1800">
-                <a:solidFill>
-                  <a:srgbClr val="333333"/>
-                </a:solidFill>
-                <a:latin typeface="Microsoft YaHei"/>
-              </a:defRPr>
-            </a:pPr>
-            <a:r>
-              <a:t>紧凑结构：9-12月课程密集，1-3月深化项目，5-9月论文/实习/就业冲刺</a:t>
-            </a:r>
-          </a:p>
-          <a:p>
-            <a:pPr>
-              <a:spcAft>
-                <a:spcPts val="1200"/>
-              </a:spcAft>
-              <a:defRPr sz="1800">
-                <a:solidFill>
-                  <a:srgbClr val="333333"/>
-                </a:solidFill>
-                <a:latin typeface="Microsoft YaHei"/>
-              </a:defRPr>
-            </a:pPr>
-            <a:r>
-              <a:t>毕业生签证（Graduate Route）：完成学位后可申请留英2年（博士3年）寻找工作</a:t>
-            </a:r>
-          </a:p>
-          <a:p>
-            <a:pPr>
-              <a:spcAft>
-                <a:spcPts val="1200"/>
-              </a:spcAft>
-              <a:defRPr sz="1800">
-                <a:solidFill>
-                  <a:srgbClr val="333333"/>
-                </a:solidFill>
-                <a:latin typeface="Microsoft YaHei"/>
-              </a:defRPr>
-            </a:pPr>
-            <a:r>
-              <a:t>行业连接：伦敦及各大校区与咨询公司、金融机构、科技企业合作紧密</a:t>
-            </a:r>
-          </a:p>
-          <a:p>
-            <a:pPr>
-              <a:spcAft>
-                <a:spcPts val="1200"/>
-              </a:spcAft>
-              <a:defRPr sz="1800">
-                <a:solidFill>
-                  <a:srgbClr val="333333"/>
-                </a:solidFill>
-                <a:latin typeface="Microsoft YaHei"/>
-              </a:defRPr>
-            </a:pPr>
-            <a:r>
-              <a:t>高强度学习节奏：学期短、评估密，需提前具备扎实的量化与编程基础</a:t>
+              <a:t>项目：MSc Business Analytics &amp; AI（原MSc Business Analytics，2026入学起更名并强化AI方向）｜帝国理工商学院</a:t>
+            </a:r>
+          </a:p>
+          <a:p>
+            <a:pPr>
+              <a:spcAft>
+                <a:spcPts val="1200"/>
+              </a:spcAft>
+              <a:defRPr sz="1800">
+                <a:solidFill>
+                  <a:srgbClr val="333333"/>
+                </a:solidFill>
+                <a:latin typeface="Microsoft YaHei"/>
+              </a:defRPr>
+            </a:pPr>
+            <a:r>
+              <a:t>时长：12个月（可选16个月延长实习路径，需另缴学费）；地点：伦敦South Kensington</a:t>
+            </a:r>
+          </a:p>
+          <a:p>
+            <a:pPr>
+              <a:spcAft>
+                <a:spcPts val="1200"/>
+              </a:spcAft>
+              <a:defRPr sz="1800">
+                <a:solidFill>
+                  <a:srgbClr val="333333"/>
+                </a:solidFill>
+                <a:latin typeface="Microsoft YaHei"/>
+              </a:defRPr>
+            </a:pPr>
+            <a:r>
+              <a:t>学费：2026年入学国际生£47,000（官方已公布）；2027年学费未公布</a:t>
+            </a:r>
+          </a:p>
+          <a:p>
+            <a:pPr>
+              <a:spcAft>
+                <a:spcPts val="1200"/>
+              </a:spcAft>
+              <a:defRPr sz="1800">
+                <a:solidFill>
+                  <a:srgbClr val="333333"/>
+                </a:solidFill>
+                <a:latin typeface="Microsoft YaHei"/>
+              </a:defRPr>
+            </a:pPr>
+            <a:r>
+              <a:t>课程：数据库与SQL（PostgreSQL/Spark）、Python与R编程、机器学习、深度学习与生成式AI、优化与决策模型、统计与计量；10门选修</a:t>
+            </a:r>
+          </a:p>
+          <a:p>
+            <a:pPr>
+              <a:spcAft>
+                <a:spcPts val="1200"/>
+              </a:spcAft>
+              <a:defRPr sz="1800">
+                <a:solidFill>
+                  <a:srgbClr val="333333"/>
+                </a:solidFill>
+                <a:latin typeface="Microsoft YaHei"/>
+              </a:defRPr>
+            </a:pPr>
+            <a:r>
+              <a:t>实践：夏季Analytics in Business Capstone——咨询项目或实习二选一；另有7-9月在线预修课程</a:t>
             </a:r>
           </a:p>
         </p:txBody>
@@ -7304,7 +6750,7 @@
               </a:defRPr>
             </a:pPr>
             <a:r>
-              <a:t>为什么选择英国：核心优势</a:t>
+              <a:t>Imperial：申请要求与时间窗口</a:t>
             </a:r>
           </a:p>
         </p:txBody>
@@ -7343,71 +6789,71 @@
               </a:defRPr>
             </a:pPr>
             <a:r>
-              <a:t>学制优势：一年制硕士显著降低总留学成本与时间投入</a:t>
-            </a:r>
-          </a:p>
-          <a:p>
-            <a:pPr>
-              <a:spcAft>
-                <a:spcPts val="1200"/>
-              </a:spcAft>
-              <a:defRPr sz="1800">
-                <a:solidFill>
-                  <a:srgbClr val="333333"/>
-                </a:solidFill>
-                <a:latin typeface="Microsoft YaHei"/>
-              </a:defRPr>
-            </a:pPr>
-            <a:r>
-              <a:t>签证政策：Graduate Route为留英就业提供缓冲期</a:t>
-            </a:r>
-          </a:p>
-          <a:p>
-            <a:pPr>
-              <a:spcAft>
-                <a:spcPts val="1200"/>
-              </a:spcAft>
-              <a:defRPr sz="1800">
-                <a:solidFill>
-                  <a:srgbClr val="333333"/>
-                </a:solidFill>
-                <a:latin typeface="Microsoft YaHei"/>
-              </a:defRPr>
-            </a:pPr>
-            <a:r>
-              <a:t>地理与行业资源：伦敦作为全球金融中心，聚集咨询、科技与金融科技总部</a:t>
-            </a:r>
-          </a:p>
-          <a:p>
-            <a:pPr>
-              <a:spcAft>
-                <a:spcPts val="1200"/>
-              </a:spcAft>
-              <a:defRPr sz="1800">
-                <a:solidFill>
-                  <a:srgbClr val="333333"/>
-                </a:solidFill>
-                <a:latin typeface="Microsoft YaHei"/>
-              </a:defRPr>
-            </a:pPr>
-            <a:r>
-              <a:t>项目成熟度：帝国、UCL、华威、爱丁堡等项目经过多年迭代，课程与就业支持体系完善</a:t>
-            </a:r>
-          </a:p>
-          <a:p>
-            <a:pPr>
-              <a:spcAft>
-                <a:spcPts val="1200"/>
-              </a:spcAft>
-              <a:defRPr sz="1800">
-                <a:solidFill>
-                  <a:srgbClr val="333333"/>
-                </a:solidFill>
-                <a:latin typeface="Microsoft YaHei"/>
-              </a:defRPr>
-            </a:pPr>
-            <a:r>
-              <a:t>2027 Fall申请定位：网申预计将于2026年9-10月开放，竞争持续激烈</a:t>
+              <a:t>学历：一等或2:1荣誉学位，专业须为量化方向（计算机、工程、数学、统计、物理、定量经济学）；需提交『量化经历陈述』（列出最多5门最高量化课程）</a:t>
+            </a:r>
+          </a:p>
+          <a:p>
+            <a:pPr>
+              <a:spcAft>
+                <a:spcPts val="1200"/>
+              </a:spcAft>
+              <a:defRPr sz="1800">
+                <a:solidFill>
+                  <a:srgbClr val="333333"/>
+                </a:solidFill>
+                <a:latin typeface="Microsoft YaHei"/>
+              </a:defRPr>
+            </a:pPr>
+            <a:r>
+              <a:t>语言：雅思7.0（单项不低于6.5）</a:t>
+            </a:r>
+          </a:p>
+          <a:p>
+            <a:pPr>
+              <a:spcAft>
+                <a:spcPts val="1200"/>
+              </a:spcAft>
+              <a:defRPr sz="1800">
+                <a:solidFill>
+                  <a:srgbClr val="333333"/>
+                </a:solidFill>
+                <a:latin typeface="Microsoft YaHei"/>
+              </a:defRPr>
+            </a:pPr>
+            <a:r>
+              <a:t>GMAT/GRE：非强制；官方明确量化背景不足者『强烈建议』提供，建议达到90分位</a:t>
+            </a:r>
+          </a:p>
+          <a:p>
+            <a:pPr>
+              <a:spcAft>
+                <a:spcPts val="1200"/>
+              </a:spcAft>
+              <a:defRPr sz="1800">
+                <a:solidFill>
+                  <a:srgbClr val="333333"/>
+                </a:solidFill>
+                <a:latin typeface="Microsoft YaHei"/>
+              </a:defRPr>
+            </a:pPr>
+            <a:r>
+              <a:t>流程与费用：申请费£125；短名单后在线视频面试；录取押金£6,500</a:t>
+            </a:r>
+          </a:p>
+          <a:p>
+            <a:pPr>
+              <a:spcAft>
+                <a:spcPts val="1200"/>
+              </a:spcAft>
+              <a:defRPr sz="1800">
+                <a:solidFill>
+                  <a:srgbClr val="333333"/>
+                </a:solidFill>
+                <a:latin typeface="Microsoft YaHei"/>
+              </a:defRPr>
+            </a:pPr>
+            <a:r>
+              <a:t>时间：2026入学为分轮制（第1轮2025年9月28日截止，共4轮）并结合滚动审理；2027入学轮次与日期未公布，以官网为准</a:t>
             </a:r>
           </a:p>
         </p:txBody>
@@ -7461,7 +6907,7 @@
               </a:defRPr>
             </a:pPr>
             <a:r>
-              <a:t>2027 Fall 时间背景与未知信息提示</a:t>
+              <a:t>UCL：MSc Business Analytics 项目概览</a:t>
             </a:r>
           </a:p>
         </p:txBody>
@@ -7500,71 +6946,71 @@
               </a:defRPr>
             </a:pPr>
             <a:r>
-              <a:t>申请周期预测：2027 Fall入学网申大概率于2026年9-10月开放（参考往年节奏）</a:t>
-            </a:r>
-          </a:p>
-          <a:p>
-            <a:pPr>
-              <a:spcAft>
-                <a:spcPts val="1200"/>
-              </a:spcAft>
-              <a:defRPr sz="1800">
-                <a:solidFill>
-                  <a:srgbClr val="333333"/>
-                </a:solidFill>
-                <a:latin typeface="Microsoft YaHei"/>
-              </a:defRPr>
-            </a:pPr>
-            <a:r>
-              <a:t>轮次概念：多数项目分Round 1/2/3/4，首轮名额充裕、奖学金机会更多；末轮竞争激烈且可能提前满员</a:t>
-            </a:r>
-          </a:p>
-          <a:p>
-            <a:pPr>
-              <a:spcAft>
-                <a:spcPts val="1200"/>
-              </a:spcAft>
-              <a:defRPr sz="1800">
-                <a:solidFill>
-                  <a:srgbClr val="333333"/>
-                </a:solidFill>
-                <a:latin typeface="Microsoft YaHei"/>
-              </a:defRPr>
-            </a:pPr>
-            <a:r>
-              <a:t>尚未公布（Not yet published）：2027 intake的具体开放日期、各轮次截止日期</a:t>
-            </a:r>
-          </a:p>
-          <a:p>
-            <a:pPr>
-              <a:spcAft>
-                <a:spcPts val="1200"/>
-              </a:spcAft>
-              <a:defRPr sz="1800">
-                <a:solidFill>
-                  <a:srgbClr val="333333"/>
-                </a:solidFill>
-                <a:latin typeface="Microsoft YaHei"/>
-              </a:defRPr>
-            </a:pPr>
-            <a:r>
-              <a:t>尚未公布（Not yet published）：2027/2028学年国际生学费标准，预计将于2025年底至2026年陆续更新</a:t>
-            </a:r>
-          </a:p>
-          <a:p>
-            <a:pPr>
-              <a:spcAft>
-                <a:spcPts val="1200"/>
-              </a:spcAft>
-              <a:defRPr sz="1800">
-                <a:solidFill>
-                  <a:srgbClr val="333333"/>
-                </a:solidFill>
-                <a:latin typeface="Microsoft YaHei"/>
-              </a:defRPr>
-            </a:pPr>
-            <a:r>
-              <a:t>尚未公布（Not yet published）：2027 Fall文书题目、推荐信要求细节、语言政策变动</a:t>
+              <a:t>项目：MSc Business Analytics｜UCL管理学院（UCL School of Management）</a:t>
+            </a:r>
+          </a:p>
+          <a:p>
+            <a:pPr>
+              <a:spcAft>
+                <a:spcPts val="1200"/>
+              </a:spcAft>
+              <a:defRPr sz="1800">
+                <a:solidFill>
+                  <a:srgbClr val="333333"/>
+                </a:solidFill>
+                <a:latin typeface="Microsoft YaHei"/>
+              </a:defRPr>
+            </a:pPr>
+            <a:r>
+              <a:t>地点与时长：Canary Wharf金融区（One Canada Square）授课，12个月全日制</a:t>
+            </a:r>
+          </a:p>
+          <a:p>
+            <a:pPr>
+              <a:spcAft>
+                <a:spcPts val="1200"/>
+              </a:spcAft>
+              <a:defRPr sz="1800">
+                <a:solidFill>
+                  <a:srgbClr val="333333"/>
+                </a:solidFill>
+                <a:latin typeface="Microsoft YaHei"/>
+              </a:defRPr>
+            </a:pPr>
+            <a:r>
+              <a:t>学费：2026年9月入学国际生£46,700（官方已公布）；2027年未公布</a:t>
+            </a:r>
+          </a:p>
+          <a:p>
+            <a:pPr>
+              <a:spcAft>
+                <a:spcPts val="1200"/>
+              </a:spcAft>
+              <a:defRPr sz="1800">
+                <a:solidFill>
+                  <a:srgbClr val="333333"/>
+                </a:solidFill>
+                <a:latin typeface="Microsoft YaHei"/>
+              </a:defRPr>
+            </a:pPr>
+            <a:r>
+              <a:t>课程：6门核心课（统计基础、编程与商业分析、预测分析、市场分析等）+2门选修+第三学期咨询项目/论文（12,000字报告+15分钟展示）</a:t>
+            </a:r>
+          </a:p>
+          <a:p>
+            <a:pPr>
+              <a:spcAft>
+                <a:spcPts val="1200"/>
+              </a:spcAft>
+              <a:defRPr sz="1800">
+                <a:solidFill>
+                  <a:srgbClr val="333333"/>
+                </a:solidFill>
+                <a:latin typeface="Microsoft YaHei"/>
+              </a:defRPr>
+            </a:pPr>
+            <a:r>
+              <a:t>特色：Python为核心工具，机器学习与AI在商业场景的应用，与金融区企业合作紧密</a:t>
             </a:r>
           </a:p>
         </p:txBody>
@@ -7618,7 +7064,7 @@
               </a:defRPr>
             </a:pPr>
             <a:r>
-              <a:t>Imperial College London：项目概览</a:t>
+              <a:t>UCL：申请要求与风险提示</a:t>
             </a:r>
           </a:p>
         </p:txBody>
@@ -7657,71 +7103,71 @@
               </a:defRPr>
             </a:pPr>
             <a:r>
-              <a:t>项目名称：MSc Business Analytics，帝国理工商学院（Imperial College Business School）</a:t>
-            </a:r>
-          </a:p>
-          <a:p>
-            <a:pPr>
-              <a:spcAft>
-                <a:spcPts val="1200"/>
-              </a:spcAft>
-              <a:defRPr sz="1800">
-                <a:solidFill>
-                  <a:srgbClr val="333333"/>
-                </a:solidFill>
-                <a:latin typeface="Microsoft YaHei"/>
-              </a:defRPr>
-            </a:pPr>
-            <a:r>
-              <a:t>学制与地点：全日制12个月，伦敦校区（London Campus）</a:t>
-            </a:r>
-          </a:p>
-          <a:p>
-            <a:pPr>
-              <a:spcAft>
-                <a:spcPts val="1200"/>
-              </a:spcAft>
-              <a:defRPr sz="1800">
-                <a:solidFill>
-                  <a:srgbClr val="333333"/>
-                </a:solidFill>
-                <a:latin typeface="Microsoft YaHei"/>
-              </a:defRPr>
-            </a:pPr>
-            <a:r>
-              <a:t>班级规模：约96人，平均工作年限约2年</a:t>
-            </a:r>
-          </a:p>
-          <a:p>
-            <a:pPr>
-              <a:spcAft>
-                <a:spcPts val="1200"/>
-              </a:spcAft>
-              <a:defRPr sz="1800">
-                <a:solidFill>
-                  <a:srgbClr val="333333"/>
-                </a:solidFill>
-                <a:latin typeface="Microsoft YaHei"/>
-              </a:defRPr>
-            </a:pPr>
-            <a:r>
-              <a:t>课程结构：核心模块涵盖机器学习、预测分析、数据可视化、网络分析，并包含Capstone企业实战项目</a:t>
-            </a:r>
-          </a:p>
-          <a:p>
-            <a:pPr>
-              <a:spcAft>
-                <a:spcPts val="1200"/>
-              </a:spcAft>
-              <a:defRPr sz="1800">
-                <a:solidFill>
-                  <a:srgbClr val="333333"/>
-                </a:solidFill>
-                <a:latin typeface="Microsoft YaHei"/>
-              </a:defRPr>
-            </a:pPr>
-            <a:r>
-              <a:t>2027 Fall学费基准：参考2025/2026学年，国际生学费为£47,000/年；2027学费待官方公布</a:t>
+              <a:t>学历：2:1荣誉学位或同等学历，专业不限但需较强量化分析能力（商科、工程、计算机、经济、心理等均被考虑）</a:t>
+            </a:r>
+          </a:p>
+          <a:p>
+            <a:pPr>
+              <a:spcAft>
+                <a:spcPts val="1200"/>
+              </a:spcAft>
+              <a:defRPr sz="1800">
+                <a:solidFill>
+                  <a:srgbClr val="333333"/>
+                </a:solidFill>
+                <a:latin typeface="Microsoft YaHei"/>
+              </a:defRPr>
+            </a:pPr>
+            <a:r>
+              <a:t>语言：UCL『Level 2』——雅思7.0（单项不低于6.5）</a:t>
+            </a:r>
+          </a:p>
+          <a:p>
+            <a:pPr>
+              <a:spcAft>
+                <a:spcPts val="1200"/>
+              </a:spcAft>
+              <a:defRPr sz="1800">
+                <a:solidFill>
+                  <a:srgbClr val="333333"/>
+                </a:solidFill>
+                <a:latin typeface="Microsoft YaHei"/>
+              </a:defRPr>
+            </a:pPr>
+            <a:r>
+              <a:t>GMAT/GRE：不强制，不作硬性要求</a:t>
+            </a:r>
+          </a:p>
+          <a:p>
+            <a:pPr>
+              <a:spcAft>
+                <a:spcPts val="1200"/>
+              </a:spcAft>
+              <a:defRPr sz="1800">
+                <a:solidFill>
+                  <a:srgbClr val="333333"/>
+                </a:solidFill>
+                <a:latin typeface="Microsoft YaHei"/>
+              </a:defRPr>
+            </a:pPr>
+            <a:r>
+              <a:t>时间：2026入学申请2025年10月20日开放、2026年6月26日截止（需签证者）；2027周期未公布</a:t>
+            </a:r>
+          </a:p>
+          <a:p>
+            <a:pPr>
+              <a:spcAft>
+                <a:spcPts val="1200"/>
+              </a:spcAft>
+              <a:defRPr sz="1800">
+                <a:solidFill>
+                  <a:srgbClr val="333333"/>
+                </a:solidFill>
+                <a:latin typeface="Microsoft YaHei"/>
+              </a:defRPr>
+            </a:pPr>
+            <a:r>
+              <a:t>竞争风险：申请量大、门槛高；个人陈述须清晰回答Why BA &amp; Why UCL，并说明背景如何匹配课程</a:t>
             </a:r>
           </a:p>
         </p:txBody>

</xml_diff>